<commit_message>
V3 polish: bump font sizes per spec + word-break: keep-all for Korean
</commit_message>
<xml_diff>
--- a/devotion-10/devotional_v3.pptx
+++ b/devotion-10/devotional_v3.pptx
@@ -3156,7 +3156,7 @@
         <p:spPr>
           <a:xfrm>
             <a:off x="777240" y="731519"/>
-            <a:ext cx="10637215" cy="365760"/>
+            <a:ext cx="10637215" cy="411480"/>
           </a:xfrm>
           <a:prstGeom prst="rect">
             <a:avLst/>
@@ -3175,7 +3175,7 @@
               </a:lnSpc>
             </a:pPr>
             <a:r>
-              <a:rPr sz="2000" b="1" spc="400">
+              <a:rPr sz="2200" b="1" spc="400">
                 <a:solidFill>
                   <a:srgbClr val="6C6A64"/>
                 </a:solidFill>
@@ -3256,7 +3256,7 @@
         <p:spPr>
           <a:xfrm>
             <a:off x="777240" y="3200400"/>
-            <a:ext cx="7446050" cy="548640"/>
+            <a:ext cx="9041632" cy="640080"/>
           </a:xfrm>
           <a:prstGeom prst="rect">
             <a:avLst/>
@@ -3275,7 +3275,7 @@
               </a:lnSpc>
             </a:pPr>
             <a:r>
-              <a:rPr sz="2200" b="1">
+              <a:rPr sz="2400" b="1">
                 <a:solidFill>
                   <a:srgbClr val="3D3D3A"/>
                 </a:solidFill>
@@ -3343,7 +3343,7 @@
         <p:spPr>
           <a:xfrm>
             <a:off x="1005840" y="4297680"/>
-            <a:ext cx="1560515" cy="274320"/>
+            <a:ext cx="1560515" cy="365760"/>
           </a:xfrm>
           <a:prstGeom prst="rect">
             <a:avLst/>
@@ -3362,7 +3362,7 @@
               </a:lnSpc>
             </a:pPr>
             <a:r>
-              <a:rPr sz="1400" b="1" spc="600">
+              <a:rPr sz="1800" b="1" spc="600">
                 <a:solidFill>
                   <a:srgbClr val="CC785C"/>
                 </a:solidFill>
@@ -3383,8 +3383,8 @@
         </p:nvSpPr>
         <p:spPr>
           <a:xfrm>
-            <a:off x="1005840" y="4617720"/>
-            <a:ext cx="1560515" cy="274320"/>
+            <a:off x="1005840" y="4709160"/>
+            <a:ext cx="1560515" cy="365760"/>
           </a:xfrm>
           <a:prstGeom prst="rect">
             <a:avLst/>
@@ -3403,7 +3403,7 @@
               </a:lnSpc>
             </a:pPr>
             <a:r>
-              <a:rPr sz="1200" b="1" spc="400">
+              <a:rPr sz="1600" b="1" spc="400">
                 <a:solidFill>
                   <a:srgbClr val="6C6A64"/>
                 </a:solidFill>
@@ -3424,8 +3424,8 @@
         </p:nvSpPr>
         <p:spPr>
           <a:xfrm>
-            <a:off x="1005840" y="5120640"/>
-            <a:ext cx="1560515" cy="1097280"/>
+            <a:off x="1005840" y="5029200"/>
+            <a:ext cx="1560515" cy="1188720"/>
           </a:xfrm>
           <a:prstGeom prst="rect">
             <a:avLst/>
@@ -3444,7 +3444,7 @@
               </a:lnSpc>
             </a:pPr>
             <a:r>
-              <a:rPr sz="2200" b="1">
+              <a:rPr sz="2400" b="1">
                 <a:solidFill>
                   <a:srgbClr val="141413"/>
                 </a:solidFill>
@@ -3462,7 +3462,7 @@
               </a:lnSpc>
             </a:pPr>
             <a:r>
-              <a:rPr sz="2200" b="1">
+              <a:rPr sz="2400" b="1">
                 <a:solidFill>
                   <a:srgbClr val="141413"/>
                 </a:solidFill>
@@ -3530,7 +3530,7 @@
         <p:spPr>
           <a:xfrm>
             <a:off x="3160715" y="4297680"/>
-            <a:ext cx="1560515" cy="274320"/>
+            <a:ext cx="1560515" cy="365760"/>
           </a:xfrm>
           <a:prstGeom prst="rect">
             <a:avLst/>
@@ -3549,7 +3549,7 @@
               </a:lnSpc>
             </a:pPr>
             <a:r>
-              <a:rPr sz="1400" b="1" spc="600">
+              <a:rPr sz="1800" b="1" spc="600">
                 <a:solidFill>
                   <a:srgbClr val="CC785C"/>
                 </a:solidFill>
@@ -3570,8 +3570,8 @@
         </p:nvSpPr>
         <p:spPr>
           <a:xfrm>
-            <a:off x="3160715" y="4617720"/>
-            <a:ext cx="1560515" cy="274320"/>
+            <a:off x="3160715" y="4709160"/>
+            <a:ext cx="1560515" cy="365760"/>
           </a:xfrm>
           <a:prstGeom prst="rect">
             <a:avLst/>
@@ -3590,7 +3590,7 @@
               </a:lnSpc>
             </a:pPr>
             <a:r>
-              <a:rPr sz="1200" b="1" spc="400">
+              <a:rPr sz="1600" b="1" spc="400">
                 <a:solidFill>
                   <a:srgbClr val="6C6A64"/>
                 </a:solidFill>
@@ -3611,8 +3611,8 @@
         </p:nvSpPr>
         <p:spPr>
           <a:xfrm>
-            <a:off x="3160715" y="5120640"/>
-            <a:ext cx="1560515" cy="1097280"/>
+            <a:off x="3160715" y="5029200"/>
+            <a:ext cx="1560515" cy="1188720"/>
           </a:xfrm>
           <a:prstGeom prst="rect">
             <a:avLst/>
@@ -3631,7 +3631,7 @@
               </a:lnSpc>
             </a:pPr>
             <a:r>
-              <a:rPr sz="2200" b="1">
+              <a:rPr sz="2400" b="1">
                 <a:solidFill>
                   <a:srgbClr val="141413"/>
                 </a:solidFill>
@@ -3649,7 +3649,7 @@
               </a:lnSpc>
             </a:pPr>
             <a:r>
-              <a:rPr sz="2200" b="1">
+              <a:rPr sz="2400" b="1">
                 <a:solidFill>
                   <a:srgbClr val="141413"/>
                 </a:solidFill>
@@ -3717,7 +3717,7 @@
         <p:spPr>
           <a:xfrm>
             <a:off x="5315590" y="4297680"/>
-            <a:ext cx="1560515" cy="274320"/>
+            <a:ext cx="1560515" cy="365760"/>
           </a:xfrm>
           <a:prstGeom prst="rect">
             <a:avLst/>
@@ -3736,7 +3736,7 @@
               </a:lnSpc>
             </a:pPr>
             <a:r>
-              <a:rPr sz="1400" b="1" spc="600">
+              <a:rPr sz="1800" b="1" spc="600">
                 <a:solidFill>
                   <a:srgbClr val="CC785C"/>
                 </a:solidFill>
@@ -3757,8 +3757,8 @@
         </p:nvSpPr>
         <p:spPr>
           <a:xfrm>
-            <a:off x="5315590" y="4617720"/>
-            <a:ext cx="1560515" cy="274320"/>
+            <a:off x="5315590" y="4709160"/>
+            <a:ext cx="1560515" cy="365760"/>
           </a:xfrm>
           <a:prstGeom prst="rect">
             <a:avLst/>
@@ -3777,7 +3777,7 @@
               </a:lnSpc>
             </a:pPr>
             <a:r>
-              <a:rPr sz="1200" b="1" spc="400">
+              <a:rPr sz="1600" b="1" spc="400">
                 <a:solidFill>
                   <a:srgbClr val="6C6A64"/>
                 </a:solidFill>
@@ -3798,8 +3798,8 @@
         </p:nvSpPr>
         <p:spPr>
           <a:xfrm>
-            <a:off x="5315590" y="5120640"/>
-            <a:ext cx="1560515" cy="1097280"/>
+            <a:off x="5315590" y="5029200"/>
+            <a:ext cx="1560515" cy="1188720"/>
           </a:xfrm>
           <a:prstGeom prst="rect">
             <a:avLst/>
@@ -3818,7 +3818,7 @@
               </a:lnSpc>
             </a:pPr>
             <a:r>
-              <a:rPr sz="2200" b="1">
+              <a:rPr sz="2400" b="1">
                 <a:solidFill>
                   <a:srgbClr val="141413"/>
                 </a:solidFill>
@@ -3836,7 +3836,7 @@
               </a:lnSpc>
             </a:pPr>
             <a:r>
-              <a:rPr sz="2200" b="1">
+              <a:rPr sz="2400" b="1">
                 <a:solidFill>
                   <a:srgbClr val="141413"/>
                 </a:solidFill>
@@ -3904,7 +3904,7 @@
         <p:spPr>
           <a:xfrm>
             <a:off x="7470465" y="4297680"/>
-            <a:ext cx="1560515" cy="274320"/>
+            <a:ext cx="1560515" cy="365760"/>
           </a:xfrm>
           <a:prstGeom prst="rect">
             <a:avLst/>
@@ -3923,7 +3923,7 @@
               </a:lnSpc>
             </a:pPr>
             <a:r>
-              <a:rPr sz="1400" b="1" spc="600">
+              <a:rPr sz="1800" b="1" spc="600">
                 <a:solidFill>
                   <a:srgbClr val="CC785C"/>
                 </a:solidFill>
@@ -3944,8 +3944,8 @@
         </p:nvSpPr>
         <p:spPr>
           <a:xfrm>
-            <a:off x="7470465" y="4617720"/>
-            <a:ext cx="1560515" cy="274320"/>
+            <a:off x="7470465" y="4709160"/>
+            <a:ext cx="1560515" cy="365760"/>
           </a:xfrm>
           <a:prstGeom prst="rect">
             <a:avLst/>
@@ -3964,7 +3964,7 @@
               </a:lnSpc>
             </a:pPr>
             <a:r>
-              <a:rPr sz="1200" b="1" spc="400">
+              <a:rPr sz="1600" b="1" spc="400">
                 <a:solidFill>
                   <a:srgbClr val="6C6A64"/>
                 </a:solidFill>
@@ -3985,8 +3985,8 @@
         </p:nvSpPr>
         <p:spPr>
           <a:xfrm>
-            <a:off x="7470465" y="5120640"/>
-            <a:ext cx="1560515" cy="1097280"/>
+            <a:off x="7470465" y="5029200"/>
+            <a:ext cx="1560515" cy="1188720"/>
           </a:xfrm>
           <a:prstGeom prst="rect">
             <a:avLst/>
@@ -4005,7 +4005,7 @@
               </a:lnSpc>
             </a:pPr>
             <a:r>
-              <a:rPr sz="2200" b="1">
+              <a:rPr sz="2400" b="1">
                 <a:solidFill>
                   <a:srgbClr val="141413"/>
                 </a:solidFill>
@@ -4023,7 +4023,7 @@
               </a:lnSpc>
             </a:pPr>
             <a:r>
-              <a:rPr sz="2200" b="1">
+              <a:rPr sz="2400" b="1">
                 <a:solidFill>
                   <a:srgbClr val="141413"/>
                 </a:solidFill>
@@ -4091,7 +4091,7 @@
         <p:spPr>
           <a:xfrm>
             <a:off x="9625340" y="4297680"/>
-            <a:ext cx="1560515" cy="274320"/>
+            <a:ext cx="1560515" cy="365760"/>
           </a:xfrm>
           <a:prstGeom prst="rect">
             <a:avLst/>
@@ -4110,7 +4110,7 @@
               </a:lnSpc>
             </a:pPr>
             <a:r>
-              <a:rPr sz="1400" b="1" spc="600">
+              <a:rPr sz="1800" b="1" spc="600">
                 <a:solidFill>
                   <a:srgbClr val="CC785C"/>
                 </a:solidFill>
@@ -4131,8 +4131,8 @@
         </p:nvSpPr>
         <p:spPr>
           <a:xfrm>
-            <a:off x="9625340" y="4617720"/>
-            <a:ext cx="1560515" cy="274320"/>
+            <a:off x="9625340" y="4709160"/>
+            <a:ext cx="1560515" cy="365760"/>
           </a:xfrm>
           <a:prstGeom prst="rect">
             <a:avLst/>
@@ -4151,7 +4151,7 @@
               </a:lnSpc>
             </a:pPr>
             <a:r>
-              <a:rPr sz="1200" b="1" spc="400">
+              <a:rPr sz="1600" b="1" spc="400">
                 <a:solidFill>
                   <a:srgbClr val="6C6A64"/>
                 </a:solidFill>
@@ -4172,8 +4172,8 @@
         </p:nvSpPr>
         <p:spPr>
           <a:xfrm>
-            <a:off x="9625340" y="5120640"/>
-            <a:ext cx="1560515" cy="1097280"/>
+            <a:off x="9625340" y="5029200"/>
+            <a:ext cx="1560515" cy="1188720"/>
           </a:xfrm>
           <a:prstGeom prst="rect">
             <a:avLst/>
@@ -4192,7 +4192,7 @@
               </a:lnSpc>
             </a:pPr>
             <a:r>
-              <a:rPr sz="2200" b="1">
+              <a:rPr sz="2400" b="1">
                 <a:solidFill>
                   <a:srgbClr val="141413"/>
                 </a:solidFill>
@@ -4210,7 +4210,7 @@
               </a:lnSpc>
             </a:pPr>
             <a:r>
-              <a:rPr sz="2200" b="1">
+              <a:rPr sz="2400" b="1">
                 <a:solidFill>
                   <a:srgbClr val="141413"/>
                 </a:solidFill>
@@ -4231,8 +4231,8 @@
         </p:nvSpPr>
         <p:spPr>
           <a:xfrm>
-            <a:off x="777240" y="6446520"/>
-            <a:ext cx="5486400" cy="274320"/>
+            <a:off x="777240" y="6355080"/>
+            <a:ext cx="6400800" cy="365760"/>
           </a:xfrm>
           <a:prstGeom prst="rect">
             <a:avLst/>
@@ -4251,7 +4251,7 @@
               </a:lnSpc>
             </a:pPr>
             <a:r>
-              <a:rPr sz="1000" b="1" spc="300">
+              <a:rPr sz="1600" b="1" spc="300">
                 <a:solidFill>
                   <a:srgbClr val="6C6A64"/>
                 </a:solidFill>
@@ -4272,8 +4272,8 @@
         </p:nvSpPr>
         <p:spPr>
           <a:xfrm>
-            <a:off x="10728655" y="6446520"/>
-            <a:ext cx="1280160" cy="274320"/>
+            <a:off x="10362895" y="6355080"/>
+            <a:ext cx="1645920" cy="365760"/>
           </a:xfrm>
           <a:prstGeom prst="rect">
             <a:avLst/>
@@ -4292,7 +4292,7 @@
               </a:lnSpc>
             </a:pPr>
             <a:r>
-              <a:rPr sz="1000" b="1" spc="300">
+              <a:rPr sz="1600" b="1" spc="300">
                 <a:solidFill>
                   <a:srgbClr val="6C6A64"/>
                 </a:solidFill>
@@ -4376,7 +4376,7 @@
         <p:spPr>
           <a:xfrm>
             <a:off x="777240" y="731519"/>
-            <a:ext cx="10637215" cy="365760"/>
+            <a:ext cx="10637215" cy="411480"/>
           </a:xfrm>
           <a:prstGeom prst="rect">
             <a:avLst/>
@@ -4395,7 +4395,7 @@
               </a:lnSpc>
             </a:pPr>
             <a:r>
-              <a:rPr sz="2000" b="1" spc="400">
+              <a:rPr sz="2200" b="1" spc="400">
                 <a:solidFill>
                   <a:srgbClr val="6C6A64"/>
                 </a:solidFill>
@@ -4416,7 +4416,7 @@
         </p:nvSpPr>
         <p:spPr>
           <a:xfrm>
-            <a:off x="777240" y="1371600"/>
+            <a:off x="777240" y="1280160"/>
             <a:ext cx="10637215" cy="1280160"/>
           </a:xfrm>
           <a:prstGeom prst="rect">
@@ -4436,7 +4436,7 @@
               </a:lnSpc>
             </a:pPr>
             <a:r>
-              <a:rPr sz="3600" b="1">
+              <a:rPr sz="3800" b="1">
                 <a:solidFill>
                   <a:srgbClr val="141413"/>
                 </a:solidFill>
@@ -4457,8 +4457,8 @@
         </p:nvSpPr>
         <p:spPr>
           <a:xfrm>
-            <a:off x="777240" y="2743200"/>
-            <a:ext cx="640080" cy="365760"/>
+            <a:off x="777240" y="2697480"/>
+            <a:ext cx="731520" cy="365760"/>
           </a:xfrm>
           <a:prstGeom prst="rect">
             <a:avLst/>
@@ -4477,7 +4477,7 @@
               </a:lnSpc>
             </a:pPr>
             <a:r>
-              <a:rPr sz="1400" b="1" spc="400">
+              <a:rPr sz="1800" b="1" spc="400">
                 <a:solidFill>
                   <a:srgbClr val="CC785C"/>
                 </a:solidFill>
@@ -4498,8 +4498,8 @@
         </p:nvSpPr>
         <p:spPr>
           <a:xfrm>
-            <a:off x="1417319" y="2697480"/>
-            <a:ext cx="9997135" cy="822960"/>
+            <a:off x="1508760" y="2651760"/>
+            <a:ext cx="9722815" cy="914400"/>
           </a:xfrm>
           <a:prstGeom prst="rect">
             <a:avLst/>
@@ -4518,7 +4518,7 @@
               </a:lnSpc>
             </a:pPr>
             <a:r>
-              <a:rPr sz="2000" b="1">
+              <a:rPr sz="2200" b="1">
                 <a:solidFill>
                   <a:srgbClr val="141413"/>
                 </a:solidFill>
@@ -4539,8 +4539,8 @@
         </p:nvSpPr>
         <p:spPr>
           <a:xfrm>
-            <a:off x="777240" y="3840480"/>
-            <a:ext cx="640080" cy="365760"/>
+            <a:off x="777240" y="3886200"/>
+            <a:ext cx="731520" cy="365760"/>
           </a:xfrm>
           <a:prstGeom prst="rect">
             <a:avLst/>
@@ -4559,7 +4559,7 @@
               </a:lnSpc>
             </a:pPr>
             <a:r>
-              <a:rPr sz="1400" b="1" spc="400">
+              <a:rPr sz="1800" b="1" spc="400">
                 <a:solidFill>
                   <a:srgbClr val="CC785C"/>
                 </a:solidFill>
@@ -4580,8 +4580,8 @@
         </p:nvSpPr>
         <p:spPr>
           <a:xfrm>
-            <a:off x="1417319" y="3794760"/>
-            <a:ext cx="9997135" cy="822960"/>
+            <a:off x="1508760" y="3840480"/>
+            <a:ext cx="9722815" cy="914400"/>
           </a:xfrm>
           <a:prstGeom prst="rect">
             <a:avLst/>
@@ -4600,7 +4600,7 @@
               </a:lnSpc>
             </a:pPr>
             <a:r>
-              <a:rPr sz="2000" b="1">
+              <a:rPr sz="2200" b="1">
                 <a:solidFill>
                   <a:srgbClr val="141413"/>
                 </a:solidFill>
@@ -4666,7 +4666,7 @@
         <p:spPr>
           <a:xfrm>
             <a:off x="777240" y="5349240"/>
-            <a:ext cx="9041632" cy="1280160"/>
+            <a:ext cx="9786237" cy="1280160"/>
           </a:xfrm>
           <a:prstGeom prst="rect">
             <a:avLst/>
@@ -4685,7 +4685,7 @@
               </a:lnSpc>
             </a:pPr>
             <a:r>
-              <a:rPr sz="2200" b="1">
+              <a:rPr sz="2600" b="1">
                 <a:solidFill>
                   <a:srgbClr val="141413"/>
                 </a:solidFill>
@@ -4703,7 +4703,7 @@
               </a:lnSpc>
             </a:pPr>
             <a:r>
-              <a:rPr sz="2200" b="1">
+              <a:rPr sz="2600" b="1">
                 <a:solidFill>
                   <a:srgbClr val="141413"/>
                 </a:solidFill>
@@ -4724,8 +4724,8 @@
         </p:nvSpPr>
         <p:spPr>
           <a:xfrm>
-            <a:off x="777240" y="6446520"/>
-            <a:ext cx="5486400" cy="274320"/>
+            <a:off x="777240" y="6355080"/>
+            <a:ext cx="6400800" cy="365760"/>
           </a:xfrm>
           <a:prstGeom prst="rect">
             <a:avLst/>
@@ -4744,7 +4744,7 @@
               </a:lnSpc>
             </a:pPr>
             <a:r>
-              <a:rPr sz="1000" b="1" spc="300">
+              <a:rPr sz="1600" b="1" spc="300">
                 <a:solidFill>
                   <a:srgbClr val="6C6A64"/>
                 </a:solidFill>
@@ -4765,8 +4765,8 @@
         </p:nvSpPr>
         <p:spPr>
           <a:xfrm>
-            <a:off x="10728655" y="6446520"/>
-            <a:ext cx="1280160" cy="274320"/>
+            <a:off x="10362895" y="6355080"/>
+            <a:ext cx="1645920" cy="365760"/>
           </a:xfrm>
           <a:prstGeom prst="rect">
             <a:avLst/>
@@ -4785,7 +4785,7 @@
               </a:lnSpc>
             </a:pPr>
             <a:r>
-              <a:rPr sz="1000" b="1" spc="300">
+              <a:rPr sz="1600" b="1" spc="300">
                 <a:solidFill>
                   <a:srgbClr val="6C6A64"/>
                 </a:solidFill>
@@ -4869,7 +4869,7 @@
         <p:spPr>
           <a:xfrm>
             <a:off x="777240" y="731519"/>
-            <a:ext cx="10637215" cy="365760"/>
+            <a:ext cx="10637215" cy="411480"/>
           </a:xfrm>
           <a:prstGeom prst="rect">
             <a:avLst/>
@@ -4888,7 +4888,7 @@
               </a:lnSpc>
             </a:pPr>
             <a:r>
-              <a:rPr sz="2000" b="1" spc="400">
+              <a:rPr sz="2200" b="1" spc="400">
                 <a:solidFill>
                   <a:srgbClr val="6C6A64"/>
                 </a:solidFill>
@@ -4909,8 +4909,8 @@
         </p:nvSpPr>
         <p:spPr>
           <a:xfrm>
-            <a:off x="777240" y="1371600"/>
-            <a:ext cx="5943600" cy="2194560"/>
+            <a:off x="777240" y="1280160"/>
+            <a:ext cx="5943600" cy="2286000"/>
           </a:xfrm>
           <a:prstGeom prst="rect">
             <a:avLst/>
@@ -4929,7 +4929,7 @@
               </a:lnSpc>
             </a:pPr>
             <a:r>
-              <a:rPr sz="5600" b="1">
+              <a:rPr sz="5800" b="1">
                 <a:solidFill>
                   <a:srgbClr val="141413"/>
                 </a:solidFill>
@@ -4947,7 +4947,7 @@
               </a:lnSpc>
             </a:pPr>
             <a:r>
-              <a:rPr sz="5600" b="1">
+              <a:rPr sz="5800" b="1">
                 <a:solidFill>
                   <a:srgbClr val="141413"/>
                 </a:solidFill>
@@ -4968,8 +4968,8 @@
         </p:nvSpPr>
         <p:spPr>
           <a:xfrm>
-            <a:off x="777240" y="3840480"/>
-            <a:ext cx="5943600" cy="914400"/>
+            <a:off x="777240" y="3749039"/>
+            <a:ext cx="5943600" cy="1005840"/>
           </a:xfrm>
           <a:prstGeom prst="rect">
             <a:avLst/>
@@ -4984,11 +4984,11 @@
           <a:p>
             <a:pPr algn="l">
               <a:lnSpc>
-                <a:spcPct val="140000"/>
-              </a:lnSpc>
-            </a:pPr>
-            <a:r>
-              <a:rPr sz="2200" b="1">
+                <a:spcPct val="145000"/>
+              </a:lnSpc>
+            </a:pPr>
+            <a:r>
+              <a:rPr sz="2400" b="1">
                 <a:solidFill>
                   <a:srgbClr val="3D3D3A"/>
                 </a:solidFill>
@@ -5009,8 +5009,8 @@
         </p:nvSpPr>
         <p:spPr>
           <a:xfrm>
-            <a:off x="777240" y="5029200"/>
-            <a:ext cx="54864" cy="1280160"/>
+            <a:off x="777240" y="4892040"/>
+            <a:ext cx="54864" cy="1463040"/>
           </a:xfrm>
           <a:prstGeom prst="rect">
             <a:avLst/>
@@ -5053,8 +5053,8 @@
         </p:nvSpPr>
         <p:spPr>
           <a:xfrm>
-            <a:off x="978408" y="4983480"/>
-            <a:ext cx="5742432" cy="1371600"/>
+            <a:off x="978408" y="4846320"/>
+            <a:ext cx="5742432" cy="1463040"/>
           </a:xfrm>
           <a:prstGeom prst="rect">
             <a:avLst/>
@@ -5069,11 +5069,11 @@
           <a:p>
             <a:pPr algn="l">
               <a:lnSpc>
-                <a:spcPct val="132000"/>
-              </a:lnSpc>
-            </a:pPr>
-            <a:r>
-              <a:rPr sz="2400" b="1">
+                <a:spcPct val="134000"/>
+              </a:lnSpc>
+            </a:pPr>
+            <a:r>
+              <a:rPr sz="2800" b="1">
                 <a:solidFill>
                   <a:srgbClr val="141413"/>
                 </a:solidFill>
@@ -5094,8 +5094,8 @@
         </p:nvSpPr>
         <p:spPr>
           <a:xfrm>
-            <a:off x="978408" y="6126480"/>
-            <a:ext cx="5742432" cy="274320"/>
+            <a:off x="978408" y="6172200"/>
+            <a:ext cx="5742432" cy="365760"/>
           </a:xfrm>
           <a:prstGeom prst="rect">
             <a:avLst/>
@@ -5114,7 +5114,7 @@
               </a:lnSpc>
             </a:pPr>
             <a:r>
-              <a:rPr sz="1400" b="1" spc="400">
+              <a:rPr sz="2100" b="1" spc="400">
                 <a:solidFill>
                   <a:srgbClr val="6C6A64"/>
                 </a:solidFill>
@@ -5159,8 +5159,8 @@
         </p:nvSpPr>
         <p:spPr>
           <a:xfrm>
-            <a:off x="777240" y="6446520"/>
-            <a:ext cx="5486400" cy="274320"/>
+            <a:off x="777240" y="6355080"/>
+            <a:ext cx="6400800" cy="365760"/>
           </a:xfrm>
           <a:prstGeom prst="rect">
             <a:avLst/>
@@ -5179,7 +5179,7 @@
               </a:lnSpc>
             </a:pPr>
             <a:r>
-              <a:rPr sz="1000" b="1" spc="300">
+              <a:rPr sz="1600" b="1" spc="300">
                 <a:solidFill>
                   <a:srgbClr val="6C6A64"/>
                 </a:solidFill>
@@ -5200,8 +5200,8 @@
         </p:nvSpPr>
         <p:spPr>
           <a:xfrm>
-            <a:off x="10728655" y="6446520"/>
-            <a:ext cx="1280160" cy="274320"/>
+            <a:off x="10362895" y="6355080"/>
+            <a:ext cx="1645920" cy="365760"/>
           </a:xfrm>
           <a:prstGeom prst="rect">
             <a:avLst/>
@@ -5220,7 +5220,7 @@
               </a:lnSpc>
             </a:pPr>
             <a:r>
-              <a:rPr sz="1000" b="1" spc="300">
+              <a:rPr sz="1600" b="1" spc="300">
                 <a:solidFill>
                   <a:srgbClr val="6C6A64"/>
                 </a:solidFill>
@@ -5304,7 +5304,7 @@
         <p:spPr>
           <a:xfrm>
             <a:off x="777240" y="731519"/>
-            <a:ext cx="10637215" cy="365760"/>
+            <a:ext cx="10637215" cy="411480"/>
           </a:xfrm>
           <a:prstGeom prst="rect">
             <a:avLst/>
@@ -5323,7 +5323,7 @@
               </a:lnSpc>
             </a:pPr>
             <a:r>
-              <a:rPr sz="2000" b="1" spc="400">
+              <a:rPr sz="2200" b="1" spc="400">
                 <a:solidFill>
                   <a:srgbClr val="6C6A64"/>
                 </a:solidFill>
@@ -5344,8 +5344,8 @@
         </p:nvSpPr>
         <p:spPr>
           <a:xfrm>
-            <a:off x="777240" y="1371600"/>
-            <a:ext cx="9041632" cy="1828800"/>
+            <a:off x="777240" y="1280160"/>
+            <a:ext cx="10637215" cy="2011680"/>
           </a:xfrm>
           <a:prstGeom prst="rect">
             <a:avLst/>
@@ -5360,11 +5360,11 @@
           <a:p>
             <a:pPr algn="l">
               <a:lnSpc>
-                <a:spcPct val="118000"/>
-              </a:lnSpc>
-            </a:pPr>
-            <a:r>
-              <a:rPr sz="4200" b="1">
+                <a:spcPct val="120000"/>
+              </a:lnSpc>
+            </a:pPr>
+            <a:r>
+              <a:rPr sz="4600" b="1">
                 <a:solidFill>
                   <a:srgbClr val="141413"/>
                 </a:solidFill>
@@ -5378,11 +5378,11 @@
           <a:p>
             <a:pPr algn="l">
               <a:lnSpc>
-                <a:spcPct val="118000"/>
-              </a:lnSpc>
-            </a:pPr>
-            <a:r>
-              <a:rPr sz="4200" b="1">
+                <a:spcPct val="120000"/>
+              </a:lnSpc>
+            </a:pPr>
+            <a:r>
+              <a:rPr sz="4600" b="1">
                 <a:solidFill>
                   <a:srgbClr val="141413"/>
                 </a:solidFill>
@@ -5403,8 +5403,8 @@
         </p:nvSpPr>
         <p:spPr>
           <a:xfrm>
-            <a:off x="777240" y="3474720"/>
-            <a:ext cx="9041632" cy="1280160"/>
+            <a:off x="777240" y="3566160"/>
+            <a:ext cx="9786237" cy="1371600"/>
           </a:xfrm>
           <a:prstGeom prst="rect">
             <a:avLst/>
@@ -5419,11 +5419,11 @@
           <a:p>
             <a:pPr algn="l">
               <a:lnSpc>
-                <a:spcPct val="160000"/>
-              </a:lnSpc>
-            </a:pPr>
-            <a:r>
-              <a:rPr sz="2000" b="1">
+                <a:spcPct val="165000"/>
+              </a:lnSpc>
+            </a:pPr>
+            <a:r>
+              <a:rPr sz="2400" b="1">
                 <a:solidFill>
                   <a:srgbClr val="3D3D3A"/>
                 </a:solidFill>
@@ -5444,8 +5444,8 @@
         </p:nvSpPr>
         <p:spPr>
           <a:xfrm>
-            <a:off x="777240" y="4937760"/>
-            <a:ext cx="9041632" cy="1463040"/>
+            <a:off x="777240" y="5120640"/>
+            <a:ext cx="9786237" cy="1280160"/>
           </a:xfrm>
           <a:prstGeom prst="rect">
             <a:avLst/>
@@ -5460,11 +5460,11 @@
           <a:p>
             <a:pPr algn="l">
               <a:lnSpc>
-                <a:spcPct val="160000"/>
-              </a:lnSpc>
-            </a:pPr>
-            <a:r>
-              <a:rPr sz="2000" b="1">
+                <a:spcPct val="165000"/>
+              </a:lnSpc>
+            </a:pPr>
+            <a:r>
+              <a:rPr sz="2400" b="1">
                 <a:solidFill>
                   <a:srgbClr val="3D3D3A"/>
                 </a:solidFill>
@@ -5485,8 +5485,8 @@
         </p:nvSpPr>
         <p:spPr>
           <a:xfrm>
-            <a:off x="777240" y="6446520"/>
-            <a:ext cx="5486400" cy="274320"/>
+            <a:off x="777240" y="6355080"/>
+            <a:ext cx="6400800" cy="365760"/>
           </a:xfrm>
           <a:prstGeom prst="rect">
             <a:avLst/>
@@ -5505,7 +5505,7 @@
               </a:lnSpc>
             </a:pPr>
             <a:r>
-              <a:rPr sz="1000" b="1" spc="300">
+              <a:rPr sz="1600" b="1" spc="300">
                 <a:solidFill>
                   <a:srgbClr val="6C6A64"/>
                 </a:solidFill>
@@ -5526,8 +5526,8 @@
         </p:nvSpPr>
         <p:spPr>
           <a:xfrm>
-            <a:off x="10728655" y="6446520"/>
-            <a:ext cx="1280160" cy="274320"/>
+            <a:off x="10362895" y="6355080"/>
+            <a:ext cx="1645920" cy="365760"/>
           </a:xfrm>
           <a:prstGeom prst="rect">
             <a:avLst/>
@@ -5546,7 +5546,7 @@
               </a:lnSpc>
             </a:pPr>
             <a:r>
-              <a:rPr sz="1000" b="1" spc="300">
+              <a:rPr sz="1600" b="1" spc="300">
                 <a:solidFill>
                   <a:srgbClr val="6C6A64"/>
                 </a:solidFill>
@@ -5630,7 +5630,7 @@
         <p:spPr>
           <a:xfrm>
             <a:off x="777240" y="731519"/>
-            <a:ext cx="10637215" cy="365760"/>
+            <a:ext cx="10637215" cy="411480"/>
           </a:xfrm>
           <a:prstGeom prst="rect">
             <a:avLst/>
@@ -5649,7 +5649,7 @@
               </a:lnSpc>
             </a:pPr>
             <a:r>
-              <a:rPr sz="2000" b="1" spc="400">
+              <a:rPr sz="2200" b="1" spc="400">
                 <a:solidFill>
                   <a:srgbClr val="6C6A64"/>
                 </a:solidFill>
@@ -5670,7 +5670,7 @@
         </p:nvSpPr>
         <p:spPr>
           <a:xfrm>
-            <a:off x="777240" y="1371600"/>
+            <a:off x="777240" y="1280160"/>
             <a:ext cx="10637215" cy="1280160"/>
           </a:xfrm>
           <a:prstGeom prst="rect">
@@ -5690,7 +5690,7 @@
               </a:lnSpc>
             </a:pPr>
             <a:r>
-              <a:rPr sz="3600" b="1">
+              <a:rPr sz="3800" b="1">
                 <a:solidFill>
                   <a:srgbClr val="141413"/>
                 </a:solidFill>
@@ -5711,8 +5711,8 @@
         </p:nvSpPr>
         <p:spPr>
           <a:xfrm>
-            <a:off x="777240" y="2743200"/>
-            <a:ext cx="640080" cy="365760"/>
+            <a:off x="777240" y="2697480"/>
+            <a:ext cx="731520" cy="365760"/>
           </a:xfrm>
           <a:prstGeom prst="rect">
             <a:avLst/>
@@ -5731,7 +5731,7 @@
               </a:lnSpc>
             </a:pPr>
             <a:r>
-              <a:rPr sz="1400" b="1" spc="400">
+              <a:rPr sz="1800" b="1" spc="400">
                 <a:solidFill>
                   <a:srgbClr val="CC785C"/>
                 </a:solidFill>
@@ -5752,8 +5752,8 @@
         </p:nvSpPr>
         <p:spPr>
           <a:xfrm>
-            <a:off x="1417319" y="2697480"/>
-            <a:ext cx="9997135" cy="822960"/>
+            <a:off x="1508760" y="2651760"/>
+            <a:ext cx="9722815" cy="914400"/>
           </a:xfrm>
           <a:prstGeom prst="rect">
             <a:avLst/>
@@ -5772,7 +5772,7 @@
               </a:lnSpc>
             </a:pPr>
             <a:r>
-              <a:rPr sz="2000" b="1">
+              <a:rPr sz="2200" b="1">
                 <a:solidFill>
                   <a:srgbClr val="141413"/>
                 </a:solidFill>
@@ -5793,8 +5793,8 @@
         </p:nvSpPr>
         <p:spPr>
           <a:xfrm>
-            <a:off x="777240" y="3840480"/>
-            <a:ext cx="640080" cy="365760"/>
+            <a:off x="777240" y="3886200"/>
+            <a:ext cx="731520" cy="365760"/>
           </a:xfrm>
           <a:prstGeom prst="rect">
             <a:avLst/>
@@ -5813,7 +5813,7 @@
               </a:lnSpc>
             </a:pPr>
             <a:r>
-              <a:rPr sz="1400" b="1" spc="400">
+              <a:rPr sz="1800" b="1" spc="400">
                 <a:solidFill>
                   <a:srgbClr val="CC785C"/>
                 </a:solidFill>
@@ -5834,8 +5834,8 @@
         </p:nvSpPr>
         <p:spPr>
           <a:xfrm>
-            <a:off x="1417319" y="3794760"/>
-            <a:ext cx="9997135" cy="822960"/>
+            <a:off x="1508760" y="3840480"/>
+            <a:ext cx="9722815" cy="914400"/>
           </a:xfrm>
           <a:prstGeom prst="rect">
             <a:avLst/>
@@ -5854,7 +5854,7 @@
               </a:lnSpc>
             </a:pPr>
             <a:r>
-              <a:rPr sz="2000" b="1">
+              <a:rPr sz="2200" b="1">
                 <a:solidFill>
                   <a:srgbClr val="141413"/>
                 </a:solidFill>
@@ -5920,7 +5920,7 @@
         <p:spPr>
           <a:xfrm>
             <a:off x="777240" y="5349240"/>
-            <a:ext cx="9041632" cy="1280160"/>
+            <a:ext cx="9786237" cy="1280160"/>
           </a:xfrm>
           <a:prstGeom prst="rect">
             <a:avLst/>
@@ -5939,7 +5939,7 @@
               </a:lnSpc>
             </a:pPr>
             <a:r>
-              <a:rPr sz="2200" b="1">
+              <a:rPr sz="2600" b="1">
                 <a:solidFill>
                   <a:srgbClr val="141413"/>
                 </a:solidFill>
@@ -5957,7 +5957,7 @@
               </a:lnSpc>
             </a:pPr>
             <a:r>
-              <a:rPr sz="2200" b="1">
+              <a:rPr sz="2600" b="1">
                 <a:solidFill>
                   <a:srgbClr val="141413"/>
                 </a:solidFill>
@@ -5978,8 +5978,8 @@
         </p:nvSpPr>
         <p:spPr>
           <a:xfrm>
-            <a:off x="777240" y="6446520"/>
-            <a:ext cx="5486400" cy="274320"/>
+            <a:off x="777240" y="6355080"/>
+            <a:ext cx="6400800" cy="365760"/>
           </a:xfrm>
           <a:prstGeom prst="rect">
             <a:avLst/>
@@ -5998,7 +5998,7 @@
               </a:lnSpc>
             </a:pPr>
             <a:r>
-              <a:rPr sz="1000" b="1" spc="300">
+              <a:rPr sz="1600" b="1" spc="300">
                 <a:solidFill>
                   <a:srgbClr val="6C6A64"/>
                 </a:solidFill>
@@ -6019,8 +6019,8 @@
         </p:nvSpPr>
         <p:spPr>
           <a:xfrm>
-            <a:off x="10728655" y="6446520"/>
-            <a:ext cx="1280160" cy="274320"/>
+            <a:off x="10362895" y="6355080"/>
+            <a:ext cx="1645920" cy="365760"/>
           </a:xfrm>
           <a:prstGeom prst="rect">
             <a:avLst/>
@@ -6039,7 +6039,7 @@
               </a:lnSpc>
             </a:pPr>
             <a:r>
-              <a:rPr sz="1000" b="1" spc="300">
+              <a:rPr sz="1600" b="1" spc="300">
                 <a:solidFill>
                   <a:srgbClr val="6C6A64"/>
                 </a:solidFill>
@@ -6123,7 +6123,7 @@
         <p:spPr>
           <a:xfrm>
             <a:off x="777240" y="731519"/>
-            <a:ext cx="10637215" cy="365760"/>
+            <a:ext cx="10637215" cy="411480"/>
           </a:xfrm>
           <a:prstGeom prst="rect">
             <a:avLst/>
@@ -6142,7 +6142,7 @@
               </a:lnSpc>
             </a:pPr>
             <a:r>
-              <a:rPr sz="2000" b="1" spc="400">
+              <a:rPr sz="2200" b="1" spc="400">
                 <a:solidFill>
                   <a:srgbClr val="6C6A64"/>
                 </a:solidFill>
@@ -6163,8 +6163,8 @@
         </p:nvSpPr>
         <p:spPr>
           <a:xfrm>
-            <a:off x="777240" y="1371600"/>
-            <a:ext cx="5943600" cy="2194560"/>
+            <a:off x="777240" y="1280160"/>
+            <a:ext cx="5943600" cy="2286000"/>
           </a:xfrm>
           <a:prstGeom prst="rect">
             <a:avLst/>
@@ -6183,7 +6183,7 @@
               </a:lnSpc>
             </a:pPr>
             <a:r>
-              <a:rPr sz="5600" b="1">
+              <a:rPr sz="5800" b="1">
                 <a:solidFill>
                   <a:srgbClr val="141413"/>
                 </a:solidFill>
@@ -6201,7 +6201,7 @@
               </a:lnSpc>
             </a:pPr>
             <a:r>
-              <a:rPr sz="5600" b="1">
+              <a:rPr sz="5800" b="1">
                 <a:solidFill>
                   <a:srgbClr val="141413"/>
                 </a:solidFill>
@@ -6222,8 +6222,8 @@
         </p:nvSpPr>
         <p:spPr>
           <a:xfrm>
-            <a:off x="777240" y="3840480"/>
-            <a:ext cx="5943600" cy="914400"/>
+            <a:off x="777240" y="3749039"/>
+            <a:ext cx="5943600" cy="1005840"/>
           </a:xfrm>
           <a:prstGeom prst="rect">
             <a:avLst/>
@@ -6238,11 +6238,11 @@
           <a:p>
             <a:pPr algn="l">
               <a:lnSpc>
-                <a:spcPct val="140000"/>
-              </a:lnSpc>
-            </a:pPr>
-            <a:r>
-              <a:rPr sz="2200" b="1">
+                <a:spcPct val="145000"/>
+              </a:lnSpc>
+            </a:pPr>
+            <a:r>
+              <a:rPr sz="2400" b="1">
                 <a:solidFill>
                   <a:srgbClr val="3D3D3A"/>
                 </a:solidFill>
@@ -6263,8 +6263,8 @@
         </p:nvSpPr>
         <p:spPr>
           <a:xfrm>
-            <a:off x="777240" y="5029200"/>
-            <a:ext cx="54864" cy="1280160"/>
+            <a:off x="777240" y="4892040"/>
+            <a:ext cx="54864" cy="1463040"/>
           </a:xfrm>
           <a:prstGeom prst="rect">
             <a:avLst/>
@@ -6307,8 +6307,8 @@
         </p:nvSpPr>
         <p:spPr>
           <a:xfrm>
-            <a:off x="978408" y="4983480"/>
-            <a:ext cx="5742432" cy="1371600"/>
+            <a:off x="978408" y="4846320"/>
+            <a:ext cx="5742432" cy="1463040"/>
           </a:xfrm>
           <a:prstGeom prst="rect">
             <a:avLst/>
@@ -6323,11 +6323,11 @@
           <a:p>
             <a:pPr algn="l">
               <a:lnSpc>
-                <a:spcPct val="132000"/>
-              </a:lnSpc>
-            </a:pPr>
-            <a:r>
-              <a:rPr sz="2400" b="1">
+                <a:spcPct val="134000"/>
+              </a:lnSpc>
+            </a:pPr>
+            <a:r>
+              <a:rPr sz="2800" b="1">
                 <a:solidFill>
                   <a:srgbClr val="141413"/>
                 </a:solidFill>
@@ -6348,8 +6348,8 @@
         </p:nvSpPr>
         <p:spPr>
           <a:xfrm>
-            <a:off x="978408" y="6126480"/>
-            <a:ext cx="5742432" cy="274320"/>
+            <a:off x="978408" y="6172200"/>
+            <a:ext cx="5742432" cy="365760"/>
           </a:xfrm>
           <a:prstGeom prst="rect">
             <a:avLst/>
@@ -6368,7 +6368,7 @@
               </a:lnSpc>
             </a:pPr>
             <a:r>
-              <a:rPr sz="1400" b="1" spc="400">
+              <a:rPr sz="2100" b="1" spc="400">
                 <a:solidFill>
                   <a:srgbClr val="6C6A64"/>
                 </a:solidFill>
@@ -6413,8 +6413,8 @@
         </p:nvSpPr>
         <p:spPr>
           <a:xfrm>
-            <a:off x="777240" y="6446520"/>
-            <a:ext cx="5486400" cy="274320"/>
+            <a:off x="777240" y="6355080"/>
+            <a:ext cx="6400800" cy="365760"/>
           </a:xfrm>
           <a:prstGeom prst="rect">
             <a:avLst/>
@@ -6433,7 +6433,7 @@
               </a:lnSpc>
             </a:pPr>
             <a:r>
-              <a:rPr sz="1000" b="1" spc="300">
+              <a:rPr sz="1600" b="1" spc="300">
                 <a:solidFill>
                   <a:srgbClr val="6C6A64"/>
                 </a:solidFill>
@@ -6454,8 +6454,8 @@
         </p:nvSpPr>
         <p:spPr>
           <a:xfrm>
-            <a:off x="10728655" y="6446520"/>
-            <a:ext cx="1280160" cy="274320"/>
+            <a:off x="10362895" y="6355080"/>
+            <a:ext cx="1645920" cy="365760"/>
           </a:xfrm>
           <a:prstGeom prst="rect">
             <a:avLst/>
@@ -6474,7 +6474,7 @@
               </a:lnSpc>
             </a:pPr>
             <a:r>
-              <a:rPr sz="1000" b="1" spc="300">
+              <a:rPr sz="1600" b="1" spc="300">
                 <a:solidFill>
                   <a:srgbClr val="6C6A64"/>
                 </a:solidFill>
@@ -6558,7 +6558,7 @@
         <p:spPr>
           <a:xfrm>
             <a:off x="777240" y="731519"/>
-            <a:ext cx="10637215" cy="365760"/>
+            <a:ext cx="10637215" cy="411480"/>
           </a:xfrm>
           <a:prstGeom prst="rect">
             <a:avLst/>
@@ -6577,7 +6577,7 @@
               </a:lnSpc>
             </a:pPr>
             <a:r>
-              <a:rPr sz="2000" b="1" spc="400">
+              <a:rPr sz="2200" b="1" spc="400">
                 <a:solidFill>
                   <a:srgbClr val="6C6A64"/>
                 </a:solidFill>
@@ -6598,8 +6598,8 @@
         </p:nvSpPr>
         <p:spPr>
           <a:xfrm>
-            <a:off x="777240" y="1371600"/>
-            <a:ext cx="9041632" cy="1828800"/>
+            <a:off x="777240" y="1280160"/>
+            <a:ext cx="10637215" cy="2011680"/>
           </a:xfrm>
           <a:prstGeom prst="rect">
             <a:avLst/>
@@ -6614,11 +6614,11 @@
           <a:p>
             <a:pPr algn="l">
               <a:lnSpc>
-                <a:spcPct val="118000"/>
-              </a:lnSpc>
-            </a:pPr>
-            <a:r>
-              <a:rPr sz="4200" b="1">
+                <a:spcPct val="120000"/>
+              </a:lnSpc>
+            </a:pPr>
+            <a:r>
+              <a:rPr sz="4600" b="1">
                 <a:solidFill>
                   <a:srgbClr val="141413"/>
                 </a:solidFill>
@@ -6632,11 +6632,11 @@
           <a:p>
             <a:pPr algn="l">
               <a:lnSpc>
-                <a:spcPct val="118000"/>
-              </a:lnSpc>
-            </a:pPr>
-            <a:r>
-              <a:rPr sz="4200" b="1">
+                <a:spcPct val="120000"/>
+              </a:lnSpc>
+            </a:pPr>
+            <a:r>
+              <a:rPr sz="4600" b="1">
                 <a:solidFill>
                   <a:srgbClr val="141413"/>
                 </a:solidFill>
@@ -6657,8 +6657,8 @@
         </p:nvSpPr>
         <p:spPr>
           <a:xfrm>
-            <a:off x="777240" y="3474720"/>
-            <a:ext cx="9041632" cy="1280160"/>
+            <a:off x="777240" y="3566160"/>
+            <a:ext cx="9786237" cy="1371600"/>
           </a:xfrm>
           <a:prstGeom prst="rect">
             <a:avLst/>
@@ -6673,11 +6673,11 @@
           <a:p>
             <a:pPr algn="l">
               <a:lnSpc>
-                <a:spcPct val="160000"/>
-              </a:lnSpc>
-            </a:pPr>
-            <a:r>
-              <a:rPr sz="2000" b="1">
+                <a:spcPct val="165000"/>
+              </a:lnSpc>
+            </a:pPr>
+            <a:r>
+              <a:rPr sz="2400" b="1">
                 <a:solidFill>
                   <a:srgbClr val="3D3D3A"/>
                 </a:solidFill>
@@ -6698,8 +6698,8 @@
         </p:nvSpPr>
         <p:spPr>
           <a:xfrm>
-            <a:off x="777240" y="4937760"/>
-            <a:ext cx="9041632" cy="1463040"/>
+            <a:off x="777240" y="5120640"/>
+            <a:ext cx="9786237" cy="1280160"/>
           </a:xfrm>
           <a:prstGeom prst="rect">
             <a:avLst/>
@@ -6714,11 +6714,11 @@
           <a:p>
             <a:pPr algn="l">
               <a:lnSpc>
-                <a:spcPct val="160000"/>
-              </a:lnSpc>
-            </a:pPr>
-            <a:r>
-              <a:rPr sz="2000" b="1">
+                <a:spcPct val="165000"/>
+              </a:lnSpc>
+            </a:pPr>
+            <a:r>
+              <a:rPr sz="2400" b="1">
                 <a:solidFill>
                   <a:srgbClr val="3D3D3A"/>
                 </a:solidFill>
@@ -6739,8 +6739,8 @@
         </p:nvSpPr>
         <p:spPr>
           <a:xfrm>
-            <a:off x="777240" y="6446520"/>
-            <a:ext cx="5486400" cy="274320"/>
+            <a:off x="777240" y="6355080"/>
+            <a:ext cx="6400800" cy="365760"/>
           </a:xfrm>
           <a:prstGeom prst="rect">
             <a:avLst/>
@@ -6759,7 +6759,7 @@
               </a:lnSpc>
             </a:pPr>
             <a:r>
-              <a:rPr sz="1000" b="1" spc="300">
+              <a:rPr sz="1600" b="1" spc="300">
                 <a:solidFill>
                   <a:srgbClr val="6C6A64"/>
                 </a:solidFill>
@@ -6780,8 +6780,8 @@
         </p:nvSpPr>
         <p:spPr>
           <a:xfrm>
-            <a:off x="10728655" y="6446520"/>
-            <a:ext cx="1280160" cy="274320"/>
+            <a:off x="10362895" y="6355080"/>
+            <a:ext cx="1645920" cy="365760"/>
           </a:xfrm>
           <a:prstGeom prst="rect">
             <a:avLst/>
@@ -6800,7 +6800,7 @@
               </a:lnSpc>
             </a:pPr>
             <a:r>
-              <a:rPr sz="1000" b="1" spc="300">
+              <a:rPr sz="1600" b="1" spc="300">
                 <a:solidFill>
                   <a:srgbClr val="6C6A64"/>
                 </a:solidFill>
@@ -6884,7 +6884,7 @@
         <p:spPr>
           <a:xfrm>
             <a:off x="777240" y="731519"/>
-            <a:ext cx="10637215" cy="365760"/>
+            <a:ext cx="10637215" cy="411480"/>
           </a:xfrm>
           <a:prstGeom prst="rect">
             <a:avLst/>
@@ -6903,7 +6903,7 @@
               </a:lnSpc>
             </a:pPr>
             <a:r>
-              <a:rPr sz="2000" b="1" spc="400">
+              <a:rPr sz="2200" b="1" spc="400">
                 <a:solidFill>
                   <a:srgbClr val="6C6A64"/>
                 </a:solidFill>
@@ -6924,7 +6924,7 @@
         </p:nvSpPr>
         <p:spPr>
           <a:xfrm>
-            <a:off x="777240" y="1371600"/>
+            <a:off x="777240" y="1280160"/>
             <a:ext cx="10637215" cy="1280160"/>
           </a:xfrm>
           <a:prstGeom prst="rect">
@@ -6944,7 +6944,7 @@
               </a:lnSpc>
             </a:pPr>
             <a:r>
-              <a:rPr sz="3600" b="1">
+              <a:rPr sz="3800" b="1">
                 <a:solidFill>
                   <a:srgbClr val="141413"/>
                 </a:solidFill>
@@ -6965,8 +6965,8 @@
         </p:nvSpPr>
         <p:spPr>
           <a:xfrm>
-            <a:off x="777240" y="2743200"/>
-            <a:ext cx="640080" cy="365760"/>
+            <a:off x="777240" y="2697480"/>
+            <a:ext cx="731520" cy="365760"/>
           </a:xfrm>
           <a:prstGeom prst="rect">
             <a:avLst/>
@@ -6985,7 +6985,7 @@
               </a:lnSpc>
             </a:pPr>
             <a:r>
-              <a:rPr sz="1400" b="1" spc="400">
+              <a:rPr sz="1800" b="1" spc="400">
                 <a:solidFill>
                   <a:srgbClr val="CC785C"/>
                 </a:solidFill>
@@ -7006,8 +7006,8 @@
         </p:nvSpPr>
         <p:spPr>
           <a:xfrm>
-            <a:off x="1417319" y="2697480"/>
-            <a:ext cx="9997135" cy="822960"/>
+            <a:off x="1508760" y="2651760"/>
+            <a:ext cx="9722815" cy="914400"/>
           </a:xfrm>
           <a:prstGeom prst="rect">
             <a:avLst/>
@@ -7026,7 +7026,7 @@
               </a:lnSpc>
             </a:pPr>
             <a:r>
-              <a:rPr sz="2000" b="1">
+              <a:rPr sz="2200" b="1">
                 <a:solidFill>
                   <a:srgbClr val="141413"/>
                 </a:solidFill>
@@ -7047,8 +7047,8 @@
         </p:nvSpPr>
         <p:spPr>
           <a:xfrm>
-            <a:off x="777240" y="3840480"/>
-            <a:ext cx="640080" cy="365760"/>
+            <a:off x="777240" y="3886200"/>
+            <a:ext cx="731520" cy="365760"/>
           </a:xfrm>
           <a:prstGeom prst="rect">
             <a:avLst/>
@@ -7067,7 +7067,7 @@
               </a:lnSpc>
             </a:pPr>
             <a:r>
-              <a:rPr sz="1400" b="1" spc="400">
+              <a:rPr sz="1800" b="1" spc="400">
                 <a:solidFill>
                   <a:srgbClr val="CC785C"/>
                 </a:solidFill>
@@ -7088,8 +7088,8 @@
         </p:nvSpPr>
         <p:spPr>
           <a:xfrm>
-            <a:off x="1417319" y="3794760"/>
-            <a:ext cx="9997135" cy="822960"/>
+            <a:off x="1508760" y="3840480"/>
+            <a:ext cx="9722815" cy="914400"/>
           </a:xfrm>
           <a:prstGeom prst="rect">
             <a:avLst/>
@@ -7108,7 +7108,7 @@
               </a:lnSpc>
             </a:pPr>
             <a:r>
-              <a:rPr sz="2000" b="1">
+              <a:rPr sz="2200" b="1">
                 <a:solidFill>
                   <a:srgbClr val="141413"/>
                 </a:solidFill>
@@ -7174,7 +7174,7 @@
         <p:spPr>
           <a:xfrm>
             <a:off x="777240" y="5349240"/>
-            <a:ext cx="9041632" cy="1280160"/>
+            <a:ext cx="9786237" cy="1280160"/>
           </a:xfrm>
           <a:prstGeom prst="rect">
             <a:avLst/>
@@ -7193,7 +7193,7 @@
               </a:lnSpc>
             </a:pPr>
             <a:r>
-              <a:rPr sz="2200" b="1">
+              <a:rPr sz="2600" b="1">
                 <a:solidFill>
                   <a:srgbClr val="141413"/>
                 </a:solidFill>
@@ -7211,7 +7211,7 @@
               </a:lnSpc>
             </a:pPr>
             <a:r>
-              <a:rPr sz="2200" b="1">
+              <a:rPr sz="2600" b="1">
                 <a:solidFill>
                   <a:srgbClr val="141413"/>
                 </a:solidFill>
@@ -7232,8 +7232,8 @@
         </p:nvSpPr>
         <p:spPr>
           <a:xfrm>
-            <a:off x="777240" y="6446520"/>
-            <a:ext cx="5486400" cy="274320"/>
+            <a:off x="777240" y="6355080"/>
+            <a:ext cx="6400800" cy="365760"/>
           </a:xfrm>
           <a:prstGeom prst="rect">
             <a:avLst/>
@@ -7252,7 +7252,7 @@
               </a:lnSpc>
             </a:pPr>
             <a:r>
-              <a:rPr sz="1000" b="1" spc="300">
+              <a:rPr sz="1600" b="1" spc="300">
                 <a:solidFill>
                   <a:srgbClr val="6C6A64"/>
                 </a:solidFill>
@@ -7273,8 +7273,8 @@
         </p:nvSpPr>
         <p:spPr>
           <a:xfrm>
-            <a:off x="10728655" y="6446520"/>
-            <a:ext cx="1280160" cy="274320"/>
+            <a:off x="10362895" y="6355080"/>
+            <a:ext cx="1645920" cy="365760"/>
           </a:xfrm>
           <a:prstGeom prst="rect">
             <a:avLst/>
@@ -7293,7 +7293,7 @@
               </a:lnSpc>
             </a:pPr>
             <a:r>
-              <a:rPr sz="1000" b="1" spc="300">
+              <a:rPr sz="1600" b="1" spc="300">
                 <a:solidFill>
                   <a:srgbClr val="6C6A64"/>
                 </a:solidFill>
@@ -7377,7 +7377,7 @@
         <p:spPr>
           <a:xfrm>
             <a:off x="777240" y="731519"/>
-            <a:ext cx="10637215" cy="365760"/>
+            <a:ext cx="10637215" cy="411480"/>
           </a:xfrm>
           <a:prstGeom prst="rect">
             <a:avLst/>
@@ -7396,7 +7396,7 @@
               </a:lnSpc>
             </a:pPr>
             <a:r>
-              <a:rPr sz="2000" b="1" spc="400">
+              <a:rPr sz="2200" b="1" spc="400">
                 <a:solidFill>
                   <a:srgbClr val="6C6A64"/>
                 </a:solidFill>
@@ -7417,8 +7417,8 @@
         </p:nvSpPr>
         <p:spPr>
           <a:xfrm>
-            <a:off x="777240" y="1371600"/>
-            <a:ext cx="5943600" cy="2194560"/>
+            <a:off x="777240" y="1280160"/>
+            <a:ext cx="5943600" cy="2286000"/>
           </a:xfrm>
           <a:prstGeom prst="rect">
             <a:avLst/>
@@ -7437,7 +7437,7 @@
               </a:lnSpc>
             </a:pPr>
             <a:r>
-              <a:rPr sz="5600" b="1">
+              <a:rPr sz="5800" b="1">
                 <a:solidFill>
                   <a:srgbClr val="141413"/>
                 </a:solidFill>
@@ -7455,7 +7455,7 @@
               </a:lnSpc>
             </a:pPr>
             <a:r>
-              <a:rPr sz="5600" b="1">
+              <a:rPr sz="5800" b="1">
                 <a:solidFill>
                   <a:srgbClr val="141413"/>
                 </a:solidFill>
@@ -7476,8 +7476,8 @@
         </p:nvSpPr>
         <p:spPr>
           <a:xfrm>
-            <a:off x="777240" y="3840480"/>
-            <a:ext cx="5943600" cy="914400"/>
+            <a:off x="777240" y="3749039"/>
+            <a:ext cx="5943600" cy="1005840"/>
           </a:xfrm>
           <a:prstGeom prst="rect">
             <a:avLst/>
@@ -7492,11 +7492,11 @@
           <a:p>
             <a:pPr algn="l">
               <a:lnSpc>
-                <a:spcPct val="140000"/>
-              </a:lnSpc>
-            </a:pPr>
-            <a:r>
-              <a:rPr sz="2200" b="1">
+                <a:spcPct val="145000"/>
+              </a:lnSpc>
+            </a:pPr>
+            <a:r>
+              <a:rPr sz="2400" b="1">
                 <a:solidFill>
                   <a:srgbClr val="3D3D3A"/>
                 </a:solidFill>
@@ -7517,8 +7517,8 @@
         </p:nvSpPr>
         <p:spPr>
           <a:xfrm>
-            <a:off x="777240" y="5029200"/>
-            <a:ext cx="54864" cy="1280160"/>
+            <a:off x="777240" y="4892040"/>
+            <a:ext cx="54864" cy="1463040"/>
           </a:xfrm>
           <a:prstGeom prst="rect">
             <a:avLst/>
@@ -7561,8 +7561,8 @@
         </p:nvSpPr>
         <p:spPr>
           <a:xfrm>
-            <a:off x="978408" y="4983480"/>
-            <a:ext cx="5742432" cy="1371600"/>
+            <a:off x="978408" y="4846320"/>
+            <a:ext cx="5742432" cy="1463040"/>
           </a:xfrm>
           <a:prstGeom prst="rect">
             <a:avLst/>
@@ -7577,11 +7577,11 @@
           <a:p>
             <a:pPr algn="l">
               <a:lnSpc>
-                <a:spcPct val="132000"/>
-              </a:lnSpc>
-            </a:pPr>
-            <a:r>
-              <a:rPr sz="2400" b="1">
+                <a:spcPct val="134000"/>
+              </a:lnSpc>
+            </a:pPr>
+            <a:r>
+              <a:rPr sz="2800" b="1">
                 <a:solidFill>
                   <a:srgbClr val="141413"/>
                 </a:solidFill>
@@ -7602,8 +7602,8 @@
         </p:nvSpPr>
         <p:spPr>
           <a:xfrm>
-            <a:off x="978408" y="6126480"/>
-            <a:ext cx="5742432" cy="274320"/>
+            <a:off x="978408" y="6172200"/>
+            <a:ext cx="5742432" cy="365760"/>
           </a:xfrm>
           <a:prstGeom prst="rect">
             <a:avLst/>
@@ -7622,7 +7622,7 @@
               </a:lnSpc>
             </a:pPr>
             <a:r>
-              <a:rPr sz="1400" b="1" spc="400">
+              <a:rPr sz="2100" b="1" spc="400">
                 <a:solidFill>
                   <a:srgbClr val="6C6A64"/>
                 </a:solidFill>
@@ -7667,8 +7667,8 @@
         </p:nvSpPr>
         <p:spPr>
           <a:xfrm>
-            <a:off x="777240" y="6446520"/>
-            <a:ext cx="5486400" cy="274320"/>
+            <a:off x="777240" y="6355080"/>
+            <a:ext cx="6400800" cy="365760"/>
           </a:xfrm>
           <a:prstGeom prst="rect">
             <a:avLst/>
@@ -7687,7 +7687,7 @@
               </a:lnSpc>
             </a:pPr>
             <a:r>
-              <a:rPr sz="1000" b="1" spc="300">
+              <a:rPr sz="1600" b="1" spc="300">
                 <a:solidFill>
                   <a:srgbClr val="6C6A64"/>
                 </a:solidFill>
@@ -7708,8 +7708,8 @@
         </p:nvSpPr>
         <p:spPr>
           <a:xfrm>
-            <a:off x="10728655" y="6446520"/>
-            <a:ext cx="1280160" cy="274320"/>
+            <a:off x="10362895" y="6355080"/>
+            <a:ext cx="1645920" cy="365760"/>
           </a:xfrm>
           <a:prstGeom prst="rect">
             <a:avLst/>
@@ -7728,7 +7728,7 @@
               </a:lnSpc>
             </a:pPr>
             <a:r>
-              <a:rPr sz="1000" b="1" spc="300">
+              <a:rPr sz="1600" b="1" spc="300">
                 <a:solidFill>
                   <a:srgbClr val="6C6A64"/>
                 </a:solidFill>
@@ -7812,7 +7812,7 @@
         <p:spPr>
           <a:xfrm>
             <a:off x="777240" y="731519"/>
-            <a:ext cx="10637215" cy="365760"/>
+            <a:ext cx="10637215" cy="411480"/>
           </a:xfrm>
           <a:prstGeom prst="rect">
             <a:avLst/>
@@ -7831,7 +7831,7 @@
               </a:lnSpc>
             </a:pPr>
             <a:r>
-              <a:rPr sz="2000" b="1" spc="400">
+              <a:rPr sz="2200" b="1" spc="400">
                 <a:solidFill>
                   <a:srgbClr val="6C6A64"/>
                 </a:solidFill>
@@ -7852,8 +7852,8 @@
         </p:nvSpPr>
         <p:spPr>
           <a:xfrm>
-            <a:off x="777240" y="1371600"/>
-            <a:ext cx="9041632" cy="1828800"/>
+            <a:off x="777240" y="1280160"/>
+            <a:ext cx="10637215" cy="2011680"/>
           </a:xfrm>
           <a:prstGeom prst="rect">
             <a:avLst/>
@@ -7868,11 +7868,11 @@
           <a:p>
             <a:pPr algn="l">
               <a:lnSpc>
-                <a:spcPct val="118000"/>
-              </a:lnSpc>
-            </a:pPr>
-            <a:r>
-              <a:rPr sz="4200" b="1">
+                <a:spcPct val="120000"/>
+              </a:lnSpc>
+            </a:pPr>
+            <a:r>
+              <a:rPr sz="4600" b="1">
                 <a:solidFill>
                   <a:srgbClr val="141413"/>
                 </a:solidFill>
@@ -7886,11 +7886,11 @@
           <a:p>
             <a:pPr algn="l">
               <a:lnSpc>
-                <a:spcPct val="118000"/>
-              </a:lnSpc>
-            </a:pPr>
-            <a:r>
-              <a:rPr sz="4200" b="1">
+                <a:spcPct val="120000"/>
+              </a:lnSpc>
+            </a:pPr>
+            <a:r>
+              <a:rPr sz="4600" b="1">
                 <a:solidFill>
                   <a:srgbClr val="141413"/>
                 </a:solidFill>
@@ -7911,8 +7911,8 @@
         </p:nvSpPr>
         <p:spPr>
           <a:xfrm>
-            <a:off x="777240" y="3474720"/>
-            <a:ext cx="9041632" cy="1280160"/>
+            <a:off x="777240" y="3566160"/>
+            <a:ext cx="9786237" cy="1371600"/>
           </a:xfrm>
           <a:prstGeom prst="rect">
             <a:avLst/>
@@ -7927,11 +7927,11 @@
           <a:p>
             <a:pPr algn="l">
               <a:lnSpc>
-                <a:spcPct val="160000"/>
-              </a:lnSpc>
-            </a:pPr>
-            <a:r>
-              <a:rPr sz="2000" b="1">
+                <a:spcPct val="165000"/>
+              </a:lnSpc>
+            </a:pPr>
+            <a:r>
+              <a:rPr sz="2400" b="1">
                 <a:solidFill>
                   <a:srgbClr val="3D3D3A"/>
                 </a:solidFill>
@@ -7952,8 +7952,8 @@
         </p:nvSpPr>
         <p:spPr>
           <a:xfrm>
-            <a:off x="777240" y="4937760"/>
-            <a:ext cx="9041632" cy="1463040"/>
+            <a:off x="777240" y="5120640"/>
+            <a:ext cx="9786237" cy="1280160"/>
           </a:xfrm>
           <a:prstGeom prst="rect">
             <a:avLst/>
@@ -7968,11 +7968,11 @@
           <a:p>
             <a:pPr algn="l">
               <a:lnSpc>
-                <a:spcPct val="160000"/>
-              </a:lnSpc>
-            </a:pPr>
-            <a:r>
-              <a:rPr sz="2000" b="1">
+                <a:spcPct val="165000"/>
+              </a:lnSpc>
+            </a:pPr>
+            <a:r>
+              <a:rPr sz="2400" b="1">
                 <a:solidFill>
                   <a:srgbClr val="3D3D3A"/>
                 </a:solidFill>
@@ -7993,8 +7993,8 @@
         </p:nvSpPr>
         <p:spPr>
           <a:xfrm>
-            <a:off x="777240" y="6446520"/>
-            <a:ext cx="5486400" cy="274320"/>
+            <a:off x="777240" y="6355080"/>
+            <a:ext cx="6400800" cy="365760"/>
           </a:xfrm>
           <a:prstGeom prst="rect">
             <a:avLst/>
@@ -8013,7 +8013,7 @@
               </a:lnSpc>
             </a:pPr>
             <a:r>
-              <a:rPr sz="1000" b="1" spc="300">
+              <a:rPr sz="1600" b="1" spc="300">
                 <a:solidFill>
                   <a:srgbClr val="6C6A64"/>
                 </a:solidFill>
@@ -8034,8 +8034,8 @@
         </p:nvSpPr>
         <p:spPr>
           <a:xfrm>
-            <a:off x="10728655" y="6446520"/>
-            <a:ext cx="1280160" cy="274320"/>
+            <a:off x="10362895" y="6355080"/>
+            <a:ext cx="1645920" cy="365760"/>
           </a:xfrm>
           <a:prstGeom prst="rect">
             <a:avLst/>
@@ -8054,7 +8054,7 @@
               </a:lnSpc>
             </a:pPr>
             <a:r>
-              <a:rPr sz="1000" b="1" spc="300">
+              <a:rPr sz="1600" b="1" spc="300">
                 <a:solidFill>
                   <a:srgbClr val="6C6A64"/>
                 </a:solidFill>
@@ -8138,7 +8138,7 @@
         <p:spPr>
           <a:xfrm>
             <a:off x="777240" y="731519"/>
-            <a:ext cx="10637215" cy="365760"/>
+            <a:ext cx="10637215" cy="411480"/>
           </a:xfrm>
           <a:prstGeom prst="rect">
             <a:avLst/>
@@ -8157,7 +8157,7 @@
               </a:lnSpc>
             </a:pPr>
             <a:r>
-              <a:rPr sz="2000" b="1" spc="400">
+              <a:rPr sz="2200" b="1" spc="400">
                 <a:solidFill>
                   <a:srgbClr val="6C6A64"/>
                 </a:solidFill>
@@ -8178,7 +8178,7 @@
         </p:nvSpPr>
         <p:spPr>
           <a:xfrm>
-            <a:off x="777240" y="1371600"/>
+            <a:off x="777240" y="1280160"/>
             <a:ext cx="10637215" cy="1280160"/>
           </a:xfrm>
           <a:prstGeom prst="rect">
@@ -8198,7 +8198,7 @@
               </a:lnSpc>
             </a:pPr>
             <a:r>
-              <a:rPr sz="3600" b="1">
+              <a:rPr sz="3800" b="1">
                 <a:solidFill>
                   <a:srgbClr val="141413"/>
                 </a:solidFill>
@@ -8219,8 +8219,8 @@
         </p:nvSpPr>
         <p:spPr>
           <a:xfrm>
-            <a:off x="777240" y="2743200"/>
-            <a:ext cx="640080" cy="365760"/>
+            <a:off x="777240" y="2697480"/>
+            <a:ext cx="731520" cy="365760"/>
           </a:xfrm>
           <a:prstGeom prst="rect">
             <a:avLst/>
@@ -8239,7 +8239,7 @@
               </a:lnSpc>
             </a:pPr>
             <a:r>
-              <a:rPr sz="1400" b="1" spc="400">
+              <a:rPr sz="1800" b="1" spc="400">
                 <a:solidFill>
                   <a:srgbClr val="CC785C"/>
                 </a:solidFill>
@@ -8260,8 +8260,8 @@
         </p:nvSpPr>
         <p:spPr>
           <a:xfrm>
-            <a:off x="1417319" y="2697480"/>
-            <a:ext cx="9997135" cy="822960"/>
+            <a:off x="1508760" y="2651760"/>
+            <a:ext cx="9722815" cy="914400"/>
           </a:xfrm>
           <a:prstGeom prst="rect">
             <a:avLst/>
@@ -8280,7 +8280,7 @@
               </a:lnSpc>
             </a:pPr>
             <a:r>
-              <a:rPr sz="2000" b="1">
+              <a:rPr sz="2200" b="1">
                 <a:solidFill>
                   <a:srgbClr val="141413"/>
                 </a:solidFill>
@@ -8301,8 +8301,8 @@
         </p:nvSpPr>
         <p:spPr>
           <a:xfrm>
-            <a:off x="777240" y="3840480"/>
-            <a:ext cx="640080" cy="365760"/>
+            <a:off x="777240" y="3886200"/>
+            <a:ext cx="731520" cy="365760"/>
           </a:xfrm>
           <a:prstGeom prst="rect">
             <a:avLst/>
@@ -8321,7 +8321,7 @@
               </a:lnSpc>
             </a:pPr>
             <a:r>
-              <a:rPr sz="1400" b="1" spc="400">
+              <a:rPr sz="1800" b="1" spc="400">
                 <a:solidFill>
                   <a:srgbClr val="CC785C"/>
                 </a:solidFill>
@@ -8342,8 +8342,8 @@
         </p:nvSpPr>
         <p:spPr>
           <a:xfrm>
-            <a:off x="1417319" y="3794760"/>
-            <a:ext cx="9997135" cy="822960"/>
+            <a:off x="1508760" y="3840480"/>
+            <a:ext cx="9722815" cy="914400"/>
           </a:xfrm>
           <a:prstGeom prst="rect">
             <a:avLst/>
@@ -8362,7 +8362,7 @@
               </a:lnSpc>
             </a:pPr>
             <a:r>
-              <a:rPr sz="2000" b="1">
+              <a:rPr sz="2200" b="1">
                 <a:solidFill>
                   <a:srgbClr val="141413"/>
                 </a:solidFill>
@@ -8428,7 +8428,7 @@
         <p:spPr>
           <a:xfrm>
             <a:off x="777240" y="5349240"/>
-            <a:ext cx="9041632" cy="1280160"/>
+            <a:ext cx="9786237" cy="1280160"/>
           </a:xfrm>
           <a:prstGeom prst="rect">
             <a:avLst/>
@@ -8447,7 +8447,7 @@
               </a:lnSpc>
             </a:pPr>
             <a:r>
-              <a:rPr sz="2200" b="1">
+              <a:rPr sz="2600" b="1">
                 <a:solidFill>
                   <a:srgbClr val="141413"/>
                 </a:solidFill>
@@ -8465,7 +8465,7 @@
               </a:lnSpc>
             </a:pPr>
             <a:r>
-              <a:rPr sz="2200" b="1">
+              <a:rPr sz="2600" b="1">
                 <a:solidFill>
                   <a:srgbClr val="141413"/>
                 </a:solidFill>
@@ -8486,8 +8486,8 @@
         </p:nvSpPr>
         <p:spPr>
           <a:xfrm>
-            <a:off x="777240" y="6446520"/>
-            <a:ext cx="5486400" cy="274320"/>
+            <a:off x="777240" y="6355080"/>
+            <a:ext cx="6400800" cy="365760"/>
           </a:xfrm>
           <a:prstGeom prst="rect">
             <a:avLst/>
@@ -8506,7 +8506,7 @@
               </a:lnSpc>
             </a:pPr>
             <a:r>
-              <a:rPr sz="1000" b="1" spc="300">
+              <a:rPr sz="1600" b="1" spc="300">
                 <a:solidFill>
                   <a:srgbClr val="6C6A64"/>
                 </a:solidFill>
@@ -8527,8 +8527,8 @@
         </p:nvSpPr>
         <p:spPr>
           <a:xfrm>
-            <a:off x="10728655" y="6446520"/>
-            <a:ext cx="1280160" cy="274320"/>
+            <a:off x="10362895" y="6355080"/>
+            <a:ext cx="1645920" cy="365760"/>
           </a:xfrm>
           <a:prstGeom prst="rect">
             <a:avLst/>
@@ -8547,7 +8547,7 @@
               </a:lnSpc>
             </a:pPr>
             <a:r>
-              <a:rPr sz="1000" b="1" spc="300">
+              <a:rPr sz="1600" b="1" spc="300">
                 <a:solidFill>
                   <a:srgbClr val="6C6A64"/>
                 </a:solidFill>
@@ -8631,7 +8631,7 @@
         <p:spPr>
           <a:xfrm>
             <a:off x="777240" y="731519"/>
-            <a:ext cx="10637215" cy="365760"/>
+            <a:ext cx="10637215" cy="411480"/>
           </a:xfrm>
           <a:prstGeom prst="rect">
             <a:avLst/>
@@ -8650,7 +8650,7 @@
               </a:lnSpc>
             </a:pPr>
             <a:r>
-              <a:rPr sz="2000" b="1" spc="400">
+              <a:rPr sz="2200" b="1" spc="400">
                 <a:solidFill>
                   <a:srgbClr val="6C6A64"/>
                 </a:solidFill>
@@ -8671,8 +8671,8 @@
         </p:nvSpPr>
         <p:spPr>
           <a:xfrm>
-            <a:off x="777240" y="1371600"/>
-            <a:ext cx="5943600" cy="2194560"/>
+            <a:off x="777240" y="1280160"/>
+            <a:ext cx="5943600" cy="2286000"/>
           </a:xfrm>
           <a:prstGeom prst="rect">
             <a:avLst/>
@@ -8691,7 +8691,7 @@
               </a:lnSpc>
             </a:pPr>
             <a:r>
-              <a:rPr sz="5600" b="1">
+              <a:rPr sz="5800" b="1">
                 <a:solidFill>
                   <a:srgbClr val="141413"/>
                 </a:solidFill>
@@ -8709,7 +8709,7 @@
               </a:lnSpc>
             </a:pPr>
             <a:r>
-              <a:rPr sz="5600" b="1">
+              <a:rPr sz="5800" b="1">
                 <a:solidFill>
                   <a:srgbClr val="141413"/>
                 </a:solidFill>
@@ -8730,8 +8730,8 @@
         </p:nvSpPr>
         <p:spPr>
           <a:xfrm>
-            <a:off x="777240" y="3840480"/>
-            <a:ext cx="5943600" cy="914400"/>
+            <a:off x="777240" y="3749039"/>
+            <a:ext cx="5943600" cy="1005840"/>
           </a:xfrm>
           <a:prstGeom prst="rect">
             <a:avLst/>
@@ -8746,11 +8746,11 @@
           <a:p>
             <a:pPr algn="l">
               <a:lnSpc>
-                <a:spcPct val="140000"/>
-              </a:lnSpc>
-            </a:pPr>
-            <a:r>
-              <a:rPr sz="2200" b="1">
+                <a:spcPct val="145000"/>
+              </a:lnSpc>
+            </a:pPr>
+            <a:r>
+              <a:rPr sz="2400" b="1">
                 <a:solidFill>
                   <a:srgbClr val="3D3D3A"/>
                 </a:solidFill>
@@ -8771,8 +8771,8 @@
         </p:nvSpPr>
         <p:spPr>
           <a:xfrm>
-            <a:off x="777240" y="5029200"/>
-            <a:ext cx="54864" cy="1280160"/>
+            <a:off x="777240" y="4892040"/>
+            <a:ext cx="54864" cy="1463040"/>
           </a:xfrm>
           <a:prstGeom prst="rect">
             <a:avLst/>
@@ -8815,8 +8815,8 @@
         </p:nvSpPr>
         <p:spPr>
           <a:xfrm>
-            <a:off x="978408" y="4983480"/>
-            <a:ext cx="5742432" cy="1371600"/>
+            <a:off x="978408" y="4846320"/>
+            <a:ext cx="5742432" cy="1463040"/>
           </a:xfrm>
           <a:prstGeom prst="rect">
             <a:avLst/>
@@ -8831,11 +8831,11 @@
           <a:p>
             <a:pPr algn="l">
               <a:lnSpc>
-                <a:spcPct val="132000"/>
-              </a:lnSpc>
-            </a:pPr>
-            <a:r>
-              <a:rPr sz="2400" b="1">
+                <a:spcPct val="134000"/>
+              </a:lnSpc>
+            </a:pPr>
+            <a:r>
+              <a:rPr sz="2800" b="1">
                 <a:solidFill>
                   <a:srgbClr val="141413"/>
                 </a:solidFill>
@@ -8856,8 +8856,8 @@
         </p:nvSpPr>
         <p:spPr>
           <a:xfrm>
-            <a:off x="978408" y="6126480"/>
-            <a:ext cx="5742432" cy="274320"/>
+            <a:off x="978408" y="6172200"/>
+            <a:ext cx="5742432" cy="365760"/>
           </a:xfrm>
           <a:prstGeom prst="rect">
             <a:avLst/>
@@ -8876,7 +8876,7 @@
               </a:lnSpc>
             </a:pPr>
             <a:r>
-              <a:rPr sz="1400" b="1" spc="400">
+              <a:rPr sz="2100" b="1" spc="400">
                 <a:solidFill>
                   <a:srgbClr val="6C6A64"/>
                 </a:solidFill>
@@ -8921,8 +8921,8 @@
         </p:nvSpPr>
         <p:spPr>
           <a:xfrm>
-            <a:off x="777240" y="6446520"/>
-            <a:ext cx="5486400" cy="274320"/>
+            <a:off x="777240" y="6355080"/>
+            <a:ext cx="6400800" cy="365760"/>
           </a:xfrm>
           <a:prstGeom prst="rect">
             <a:avLst/>
@@ -8941,7 +8941,7 @@
               </a:lnSpc>
             </a:pPr>
             <a:r>
-              <a:rPr sz="1000" b="1" spc="300">
+              <a:rPr sz="1600" b="1" spc="300">
                 <a:solidFill>
                   <a:srgbClr val="6C6A64"/>
                 </a:solidFill>
@@ -8962,8 +8962,8 @@
         </p:nvSpPr>
         <p:spPr>
           <a:xfrm>
-            <a:off x="10728655" y="6446520"/>
-            <a:ext cx="1280160" cy="274320"/>
+            <a:off x="10362895" y="6355080"/>
+            <a:ext cx="1645920" cy="365760"/>
           </a:xfrm>
           <a:prstGeom prst="rect">
             <a:avLst/>
@@ -8982,7 +8982,7 @@
               </a:lnSpc>
             </a:pPr>
             <a:r>
-              <a:rPr sz="1000" b="1" spc="300">
+              <a:rPr sz="1600" b="1" spc="300">
                 <a:solidFill>
                   <a:srgbClr val="6C6A64"/>
                 </a:solidFill>
@@ -9066,7 +9066,7 @@
         <p:spPr>
           <a:xfrm>
             <a:off x="777240" y="731519"/>
-            <a:ext cx="10637215" cy="365760"/>
+            <a:ext cx="10637215" cy="411480"/>
           </a:xfrm>
           <a:prstGeom prst="rect">
             <a:avLst/>
@@ -9085,7 +9085,7 @@
               </a:lnSpc>
             </a:pPr>
             <a:r>
-              <a:rPr sz="2000" b="1" spc="400">
+              <a:rPr sz="2200" b="1" spc="400">
                 <a:solidFill>
                   <a:srgbClr val="6C6A64"/>
                 </a:solidFill>
@@ -9106,8 +9106,8 @@
         </p:nvSpPr>
         <p:spPr>
           <a:xfrm>
-            <a:off x="777240" y="1371600"/>
-            <a:ext cx="9041632" cy="1828800"/>
+            <a:off x="777240" y="1280160"/>
+            <a:ext cx="10637215" cy="2011680"/>
           </a:xfrm>
           <a:prstGeom prst="rect">
             <a:avLst/>
@@ -9122,11 +9122,11 @@
           <a:p>
             <a:pPr algn="l">
               <a:lnSpc>
-                <a:spcPct val="118000"/>
-              </a:lnSpc>
-            </a:pPr>
-            <a:r>
-              <a:rPr sz="4200" b="1">
+                <a:spcPct val="120000"/>
+              </a:lnSpc>
+            </a:pPr>
+            <a:r>
+              <a:rPr sz="4600" b="1">
                 <a:solidFill>
                   <a:srgbClr val="141413"/>
                 </a:solidFill>
@@ -9140,11 +9140,11 @@
           <a:p>
             <a:pPr algn="l">
               <a:lnSpc>
-                <a:spcPct val="118000"/>
-              </a:lnSpc>
-            </a:pPr>
-            <a:r>
-              <a:rPr sz="4200" b="1">
+                <a:spcPct val="120000"/>
+              </a:lnSpc>
+            </a:pPr>
+            <a:r>
+              <a:rPr sz="4600" b="1">
                 <a:solidFill>
                   <a:srgbClr val="141413"/>
                 </a:solidFill>
@@ -9165,8 +9165,8 @@
         </p:nvSpPr>
         <p:spPr>
           <a:xfrm>
-            <a:off x="777240" y="3474720"/>
-            <a:ext cx="9041632" cy="1280160"/>
+            <a:off x="777240" y="3566160"/>
+            <a:ext cx="9786237" cy="1371600"/>
           </a:xfrm>
           <a:prstGeom prst="rect">
             <a:avLst/>
@@ -9181,11 +9181,11 @@
           <a:p>
             <a:pPr algn="l">
               <a:lnSpc>
-                <a:spcPct val="160000"/>
-              </a:lnSpc>
-            </a:pPr>
-            <a:r>
-              <a:rPr sz="2000" b="1">
+                <a:spcPct val="165000"/>
+              </a:lnSpc>
+            </a:pPr>
+            <a:r>
+              <a:rPr sz="2400" b="1">
                 <a:solidFill>
                   <a:srgbClr val="3D3D3A"/>
                 </a:solidFill>
@@ -9206,8 +9206,8 @@
         </p:nvSpPr>
         <p:spPr>
           <a:xfrm>
-            <a:off x="777240" y="4937760"/>
-            <a:ext cx="9041632" cy="1463040"/>
+            <a:off x="777240" y="5120640"/>
+            <a:ext cx="9786237" cy="1280160"/>
           </a:xfrm>
           <a:prstGeom prst="rect">
             <a:avLst/>
@@ -9222,11 +9222,11 @@
           <a:p>
             <a:pPr algn="l">
               <a:lnSpc>
-                <a:spcPct val="160000"/>
-              </a:lnSpc>
-            </a:pPr>
-            <a:r>
-              <a:rPr sz="2000" b="1">
+                <a:spcPct val="165000"/>
+              </a:lnSpc>
+            </a:pPr>
+            <a:r>
+              <a:rPr sz="2400" b="1">
                 <a:solidFill>
                   <a:srgbClr val="3D3D3A"/>
                 </a:solidFill>
@@ -9247,8 +9247,8 @@
         </p:nvSpPr>
         <p:spPr>
           <a:xfrm>
-            <a:off x="777240" y="6446520"/>
-            <a:ext cx="5486400" cy="274320"/>
+            <a:off x="777240" y="6355080"/>
+            <a:ext cx="6400800" cy="365760"/>
           </a:xfrm>
           <a:prstGeom prst="rect">
             <a:avLst/>
@@ -9267,7 +9267,7 @@
               </a:lnSpc>
             </a:pPr>
             <a:r>
-              <a:rPr sz="1000" b="1" spc="300">
+              <a:rPr sz="1600" b="1" spc="300">
                 <a:solidFill>
                   <a:srgbClr val="6C6A64"/>
                 </a:solidFill>
@@ -9288,8 +9288,8 @@
         </p:nvSpPr>
         <p:spPr>
           <a:xfrm>
-            <a:off x="10728655" y="6446520"/>
-            <a:ext cx="1280160" cy="274320"/>
+            <a:off x="10362895" y="6355080"/>
+            <a:ext cx="1645920" cy="365760"/>
           </a:xfrm>
           <a:prstGeom prst="rect">
             <a:avLst/>
@@ -9308,7 +9308,7 @@
               </a:lnSpc>
             </a:pPr>
             <a:r>
-              <a:rPr sz="1000" b="1" spc="300">
+              <a:rPr sz="1600" b="1" spc="300">
                 <a:solidFill>
                   <a:srgbClr val="6C6A64"/>
                 </a:solidFill>
@@ -9392,7 +9392,7 @@
         <p:spPr>
           <a:xfrm>
             <a:off x="777240" y="731519"/>
-            <a:ext cx="10637215" cy="365760"/>
+            <a:ext cx="10637215" cy="411480"/>
           </a:xfrm>
           <a:prstGeom prst="rect">
             <a:avLst/>
@@ -9411,7 +9411,7 @@
               </a:lnSpc>
             </a:pPr>
             <a:r>
-              <a:rPr sz="2000" b="1" spc="400">
+              <a:rPr sz="2200" b="1" spc="400">
                 <a:solidFill>
                   <a:srgbClr val="6C6A64"/>
                 </a:solidFill>
@@ -9432,7 +9432,7 @@
         </p:nvSpPr>
         <p:spPr>
           <a:xfrm>
-            <a:off x="777240" y="1371600"/>
+            <a:off x="777240" y="1280160"/>
             <a:ext cx="10637215" cy="1280160"/>
           </a:xfrm>
           <a:prstGeom prst="rect">
@@ -9452,7 +9452,7 @@
               </a:lnSpc>
             </a:pPr>
             <a:r>
-              <a:rPr sz="3600" b="1">
+              <a:rPr sz="3800" b="1">
                 <a:solidFill>
                   <a:srgbClr val="141413"/>
                 </a:solidFill>
@@ -9473,8 +9473,8 @@
         </p:nvSpPr>
         <p:spPr>
           <a:xfrm>
-            <a:off x="777240" y="2743200"/>
-            <a:ext cx="640080" cy="365760"/>
+            <a:off x="777240" y="2697480"/>
+            <a:ext cx="731520" cy="365760"/>
           </a:xfrm>
           <a:prstGeom prst="rect">
             <a:avLst/>
@@ -9493,7 +9493,7 @@
               </a:lnSpc>
             </a:pPr>
             <a:r>
-              <a:rPr sz="1400" b="1" spc="400">
+              <a:rPr sz="1800" b="1" spc="400">
                 <a:solidFill>
                   <a:srgbClr val="CC785C"/>
                 </a:solidFill>
@@ -9514,8 +9514,8 @@
         </p:nvSpPr>
         <p:spPr>
           <a:xfrm>
-            <a:off x="1417319" y="2697480"/>
-            <a:ext cx="9997135" cy="822960"/>
+            <a:off x="1508760" y="2651760"/>
+            <a:ext cx="9722815" cy="914400"/>
           </a:xfrm>
           <a:prstGeom prst="rect">
             <a:avLst/>
@@ -9534,7 +9534,7 @@
               </a:lnSpc>
             </a:pPr>
             <a:r>
-              <a:rPr sz="2000" b="1">
+              <a:rPr sz="2200" b="1">
                 <a:solidFill>
                   <a:srgbClr val="141413"/>
                 </a:solidFill>
@@ -9555,8 +9555,8 @@
         </p:nvSpPr>
         <p:spPr>
           <a:xfrm>
-            <a:off x="777240" y="3840480"/>
-            <a:ext cx="640080" cy="365760"/>
+            <a:off x="777240" y="3886200"/>
+            <a:ext cx="731520" cy="365760"/>
           </a:xfrm>
           <a:prstGeom prst="rect">
             <a:avLst/>
@@ -9575,7 +9575,7 @@
               </a:lnSpc>
             </a:pPr>
             <a:r>
-              <a:rPr sz="1400" b="1" spc="400">
+              <a:rPr sz="1800" b="1" spc="400">
                 <a:solidFill>
                   <a:srgbClr val="CC785C"/>
                 </a:solidFill>
@@ -9596,8 +9596,8 @@
         </p:nvSpPr>
         <p:spPr>
           <a:xfrm>
-            <a:off x="1417319" y="3794760"/>
-            <a:ext cx="9997135" cy="822960"/>
+            <a:off x="1508760" y="3840480"/>
+            <a:ext cx="9722815" cy="914400"/>
           </a:xfrm>
           <a:prstGeom prst="rect">
             <a:avLst/>
@@ -9616,7 +9616,7 @@
               </a:lnSpc>
             </a:pPr>
             <a:r>
-              <a:rPr sz="2000" b="1">
+              <a:rPr sz="2200" b="1">
                 <a:solidFill>
                   <a:srgbClr val="141413"/>
                 </a:solidFill>
@@ -9682,7 +9682,7 @@
         <p:spPr>
           <a:xfrm>
             <a:off x="777240" y="5349240"/>
-            <a:ext cx="9041632" cy="1280160"/>
+            <a:ext cx="9786237" cy="1280160"/>
           </a:xfrm>
           <a:prstGeom prst="rect">
             <a:avLst/>
@@ -9701,7 +9701,7 @@
               </a:lnSpc>
             </a:pPr>
             <a:r>
-              <a:rPr sz="2200" b="1">
+              <a:rPr sz="2600" b="1">
                 <a:solidFill>
                   <a:srgbClr val="141413"/>
                 </a:solidFill>
@@ -9719,7 +9719,7 @@
               </a:lnSpc>
             </a:pPr>
             <a:r>
-              <a:rPr sz="2200" b="1">
+              <a:rPr sz="2600" b="1">
                 <a:solidFill>
                   <a:srgbClr val="141413"/>
                 </a:solidFill>
@@ -9740,8 +9740,8 @@
         </p:nvSpPr>
         <p:spPr>
           <a:xfrm>
-            <a:off x="777240" y="6446520"/>
-            <a:ext cx="5486400" cy="274320"/>
+            <a:off x="777240" y="6355080"/>
+            <a:ext cx="6400800" cy="365760"/>
           </a:xfrm>
           <a:prstGeom prst="rect">
             <a:avLst/>
@@ -9760,7 +9760,7 @@
               </a:lnSpc>
             </a:pPr>
             <a:r>
-              <a:rPr sz="1000" b="1" spc="300">
+              <a:rPr sz="1600" b="1" spc="300">
                 <a:solidFill>
                   <a:srgbClr val="6C6A64"/>
                 </a:solidFill>
@@ -9781,8 +9781,8 @@
         </p:nvSpPr>
         <p:spPr>
           <a:xfrm>
-            <a:off x="10728655" y="6446520"/>
-            <a:ext cx="1280160" cy="274320"/>
+            <a:off x="10362895" y="6355080"/>
+            <a:ext cx="1645920" cy="365760"/>
           </a:xfrm>
           <a:prstGeom prst="rect">
             <a:avLst/>
@@ -9801,7 +9801,7 @@
               </a:lnSpc>
             </a:pPr>
             <a:r>
-              <a:rPr sz="1000" b="1" spc="300">
+              <a:rPr sz="1600" b="1" spc="300">
                 <a:solidFill>
                   <a:srgbClr val="6C6A64"/>
                 </a:solidFill>
@@ -9885,7 +9885,7 @@
         <p:spPr>
           <a:xfrm>
             <a:off x="777240" y="731519"/>
-            <a:ext cx="10637215" cy="365760"/>
+            <a:ext cx="10637215" cy="411480"/>
           </a:xfrm>
           <a:prstGeom prst="rect">
             <a:avLst/>
@@ -9904,7 +9904,7 @@
               </a:lnSpc>
             </a:pPr>
             <a:r>
-              <a:rPr sz="2000" b="1" spc="400">
+              <a:rPr sz="2200" b="1" spc="400">
                 <a:solidFill>
                   <a:srgbClr val="FAF9F5"/>
                 </a:solidFill>
@@ -9925,8 +9925,8 @@
         </p:nvSpPr>
         <p:spPr>
           <a:xfrm>
-            <a:off x="777240" y="1371600"/>
-            <a:ext cx="5943600" cy="2194560"/>
+            <a:off x="777240" y="1280160"/>
+            <a:ext cx="5943600" cy="2286000"/>
           </a:xfrm>
           <a:prstGeom prst="rect">
             <a:avLst/>
@@ -9945,7 +9945,7 @@
               </a:lnSpc>
             </a:pPr>
             <a:r>
-              <a:rPr sz="5600" b="1">
+              <a:rPr sz="5800" b="1">
                 <a:solidFill>
                   <a:srgbClr val="FAF9F5"/>
                 </a:solidFill>
@@ -9963,7 +9963,7 @@
               </a:lnSpc>
             </a:pPr>
             <a:r>
-              <a:rPr sz="5600" b="1">
+              <a:rPr sz="5800" b="1">
                 <a:solidFill>
                   <a:srgbClr val="FAF9F5"/>
                 </a:solidFill>
@@ -9984,8 +9984,8 @@
         </p:nvSpPr>
         <p:spPr>
           <a:xfrm>
-            <a:off x="777240" y="3840480"/>
-            <a:ext cx="5943600" cy="914400"/>
+            <a:off x="777240" y="3749039"/>
+            <a:ext cx="5943600" cy="1005840"/>
           </a:xfrm>
           <a:prstGeom prst="rect">
             <a:avLst/>
@@ -10000,11 +10000,11 @@
           <a:p>
             <a:pPr algn="l">
               <a:lnSpc>
-                <a:spcPct val="140000"/>
-              </a:lnSpc>
-            </a:pPr>
-            <a:r>
-              <a:rPr sz="2200" b="1">
+                <a:spcPct val="145000"/>
+              </a:lnSpc>
+            </a:pPr>
+            <a:r>
+              <a:rPr sz="2400" b="1">
                 <a:solidFill>
                   <a:srgbClr val="A09D96"/>
                 </a:solidFill>
@@ -10025,8 +10025,8 @@
         </p:nvSpPr>
         <p:spPr>
           <a:xfrm>
-            <a:off x="777240" y="5029200"/>
-            <a:ext cx="54864" cy="1280160"/>
+            <a:off x="777240" y="4892040"/>
+            <a:ext cx="54864" cy="1463040"/>
           </a:xfrm>
           <a:prstGeom prst="rect">
             <a:avLst/>
@@ -10069,8 +10069,8 @@
         </p:nvSpPr>
         <p:spPr>
           <a:xfrm>
-            <a:off x="978408" y="4983480"/>
-            <a:ext cx="5742432" cy="1371600"/>
+            <a:off x="978408" y="4846320"/>
+            <a:ext cx="5742432" cy="1463040"/>
           </a:xfrm>
           <a:prstGeom prst="rect">
             <a:avLst/>
@@ -10085,11 +10085,11 @@
           <a:p>
             <a:pPr algn="l">
               <a:lnSpc>
-                <a:spcPct val="132000"/>
-              </a:lnSpc>
-            </a:pPr>
-            <a:r>
-              <a:rPr sz="2400" b="1">
+                <a:spcPct val="134000"/>
+              </a:lnSpc>
+            </a:pPr>
+            <a:r>
+              <a:rPr sz="2800" b="1">
                 <a:solidFill>
                   <a:srgbClr val="FAF9F5"/>
                 </a:solidFill>
@@ -10110,8 +10110,8 @@
         </p:nvSpPr>
         <p:spPr>
           <a:xfrm>
-            <a:off x="978408" y="6126480"/>
-            <a:ext cx="5742432" cy="274320"/>
+            <a:off x="978408" y="6172200"/>
+            <a:ext cx="5742432" cy="365760"/>
           </a:xfrm>
           <a:prstGeom prst="rect">
             <a:avLst/>
@@ -10130,7 +10130,7 @@
               </a:lnSpc>
             </a:pPr>
             <a:r>
-              <a:rPr sz="1400" b="1" spc="400">
+              <a:rPr sz="2100" b="1" spc="400">
                 <a:solidFill>
                   <a:srgbClr val="A09D96"/>
                 </a:solidFill>
@@ -10175,8 +10175,8 @@
         </p:nvSpPr>
         <p:spPr>
           <a:xfrm>
-            <a:off x="777240" y="6446520"/>
-            <a:ext cx="5486400" cy="274320"/>
+            <a:off x="777240" y="6355080"/>
+            <a:ext cx="6400800" cy="365760"/>
           </a:xfrm>
           <a:prstGeom prst="rect">
             <a:avLst/>
@@ -10195,7 +10195,7 @@
               </a:lnSpc>
             </a:pPr>
             <a:r>
-              <a:rPr sz="1000" b="1" spc="300">
+              <a:rPr sz="1600" b="1" spc="300">
                 <a:solidFill>
                   <a:srgbClr val="A09D96"/>
                 </a:solidFill>
@@ -10216,8 +10216,8 @@
         </p:nvSpPr>
         <p:spPr>
           <a:xfrm>
-            <a:off x="10728655" y="6446520"/>
-            <a:ext cx="1280160" cy="274320"/>
+            <a:off x="10362895" y="6355080"/>
+            <a:ext cx="1645920" cy="365760"/>
           </a:xfrm>
           <a:prstGeom prst="rect">
             <a:avLst/>
@@ -10236,7 +10236,7 @@
               </a:lnSpc>
             </a:pPr>
             <a:r>
-              <a:rPr sz="1000" b="1" spc="300">
+              <a:rPr sz="1600" b="1" spc="300">
                 <a:solidFill>
                   <a:srgbClr val="A09D96"/>
                 </a:solidFill>
@@ -10320,7 +10320,7 @@
         <p:spPr>
           <a:xfrm>
             <a:off x="777240" y="731519"/>
-            <a:ext cx="10637215" cy="365760"/>
+            <a:ext cx="10637215" cy="411480"/>
           </a:xfrm>
           <a:prstGeom prst="rect">
             <a:avLst/>
@@ -10339,7 +10339,7 @@
               </a:lnSpc>
             </a:pPr>
             <a:r>
-              <a:rPr sz="2000" b="1" spc="400">
+              <a:rPr sz="2200" b="1" spc="400">
                 <a:solidFill>
                   <a:srgbClr val="6C6A64"/>
                 </a:solidFill>
@@ -10360,8 +10360,8 @@
         </p:nvSpPr>
         <p:spPr>
           <a:xfrm>
-            <a:off x="777240" y="1371600"/>
-            <a:ext cx="9041632" cy="1828800"/>
+            <a:off x="777240" y="1280160"/>
+            <a:ext cx="10637215" cy="2011680"/>
           </a:xfrm>
           <a:prstGeom prst="rect">
             <a:avLst/>
@@ -10376,11 +10376,11 @@
           <a:p>
             <a:pPr algn="l">
               <a:lnSpc>
-                <a:spcPct val="118000"/>
-              </a:lnSpc>
-            </a:pPr>
-            <a:r>
-              <a:rPr sz="4200" b="1">
+                <a:spcPct val="120000"/>
+              </a:lnSpc>
+            </a:pPr>
+            <a:r>
+              <a:rPr sz="4600" b="1">
                 <a:solidFill>
                   <a:srgbClr val="141413"/>
                 </a:solidFill>
@@ -10394,11 +10394,11 @@
           <a:p>
             <a:pPr algn="l">
               <a:lnSpc>
-                <a:spcPct val="118000"/>
-              </a:lnSpc>
-            </a:pPr>
-            <a:r>
-              <a:rPr sz="4200" b="1">
+                <a:spcPct val="120000"/>
+              </a:lnSpc>
+            </a:pPr>
+            <a:r>
+              <a:rPr sz="4600" b="1">
                 <a:solidFill>
                   <a:srgbClr val="141413"/>
                 </a:solidFill>
@@ -10419,8 +10419,8 @@
         </p:nvSpPr>
         <p:spPr>
           <a:xfrm>
-            <a:off x="777240" y="3474720"/>
-            <a:ext cx="9041632" cy="1280160"/>
+            <a:off x="777240" y="3566160"/>
+            <a:ext cx="9786237" cy="1371600"/>
           </a:xfrm>
           <a:prstGeom prst="rect">
             <a:avLst/>
@@ -10435,11 +10435,11 @@
           <a:p>
             <a:pPr algn="l">
               <a:lnSpc>
-                <a:spcPct val="160000"/>
-              </a:lnSpc>
-            </a:pPr>
-            <a:r>
-              <a:rPr sz="2000" b="1">
+                <a:spcPct val="165000"/>
+              </a:lnSpc>
+            </a:pPr>
+            <a:r>
+              <a:rPr sz="2400" b="1">
                 <a:solidFill>
                   <a:srgbClr val="3D3D3A"/>
                 </a:solidFill>
@@ -10460,8 +10460,8 @@
         </p:nvSpPr>
         <p:spPr>
           <a:xfrm>
-            <a:off x="777240" y="4937760"/>
-            <a:ext cx="9041632" cy="1463040"/>
+            <a:off x="777240" y="5120640"/>
+            <a:ext cx="9786237" cy="1280160"/>
           </a:xfrm>
           <a:prstGeom prst="rect">
             <a:avLst/>
@@ -10476,11 +10476,11 @@
           <a:p>
             <a:pPr algn="l">
               <a:lnSpc>
-                <a:spcPct val="160000"/>
-              </a:lnSpc>
-            </a:pPr>
-            <a:r>
-              <a:rPr sz="2000" b="1">
+                <a:spcPct val="165000"/>
+              </a:lnSpc>
+            </a:pPr>
+            <a:r>
+              <a:rPr sz="2400" b="1">
                 <a:solidFill>
                   <a:srgbClr val="3D3D3A"/>
                 </a:solidFill>
@@ -10501,8 +10501,8 @@
         </p:nvSpPr>
         <p:spPr>
           <a:xfrm>
-            <a:off x="777240" y="6446520"/>
-            <a:ext cx="5486400" cy="274320"/>
+            <a:off x="777240" y="6355080"/>
+            <a:ext cx="6400800" cy="365760"/>
           </a:xfrm>
           <a:prstGeom prst="rect">
             <a:avLst/>
@@ -10521,7 +10521,7 @@
               </a:lnSpc>
             </a:pPr>
             <a:r>
-              <a:rPr sz="1000" b="1" spc="300">
+              <a:rPr sz="1600" b="1" spc="300">
                 <a:solidFill>
                   <a:srgbClr val="6C6A64"/>
                 </a:solidFill>
@@ -10542,8 +10542,8 @@
         </p:nvSpPr>
         <p:spPr>
           <a:xfrm>
-            <a:off x="10728655" y="6446520"/>
-            <a:ext cx="1280160" cy="274320"/>
+            <a:off x="10362895" y="6355080"/>
+            <a:ext cx="1645920" cy="365760"/>
           </a:xfrm>
           <a:prstGeom prst="rect">
             <a:avLst/>
@@ -10562,7 +10562,7 @@
               </a:lnSpc>
             </a:pPr>
             <a:r>
-              <a:rPr sz="1000" b="1" spc="300">
+              <a:rPr sz="1600" b="1" spc="300">
                 <a:solidFill>
                   <a:srgbClr val="6C6A64"/>
                 </a:solidFill>

</xml_diff>